<commit_message>
WIP: Foundry MCP server, direct-demo agents, azd infra, tests, uv.lock
</commit_message>
<xml_diff>
--- a/presentation/skill-first-ai.pptx
+++ b/presentation/skill-first-ai.pptx
@@ -5,25 +5,25 @@
     <p:sldMasterId id="2147483648" r:id="rId1"/>
   </p:sldMasterIdLst>
   <p:sldIdLst>
-    <p:sldId id="256" r:id="rId7"/>
-    <p:sldId id="257" r:id="rId8"/>
-    <p:sldId id="258" r:id="rId9"/>
-    <p:sldId id="259" r:id="rId10"/>
-    <p:sldId id="260" r:id="rId11"/>
-    <p:sldId id="261" r:id="rId12"/>
-    <p:sldId id="262" r:id="rId13"/>
-    <p:sldId id="263" r:id="rId14"/>
-    <p:sldId id="264" r:id="rId15"/>
-    <p:sldId id="265" r:id="rId16"/>
-    <p:sldId id="266" r:id="rId17"/>
-    <p:sldId id="267" r:id="rId18"/>
-    <p:sldId id="268" r:id="rId19"/>
-    <p:sldId id="269" r:id="rId20"/>
-    <p:sldId id="270" r:id="rId21"/>
-    <p:sldId id="271" r:id="rId22"/>
-    <p:sldId id="272" r:id="rId23"/>
+    <p:sldId id="256" r:id="rId2"/>
+    <p:sldId id="257" r:id="rId3"/>
+    <p:sldId id="258" r:id="rId4"/>
+    <p:sldId id="259" r:id="rId5"/>
+    <p:sldId id="260" r:id="rId6"/>
+    <p:sldId id="261" r:id="rId7"/>
+    <p:sldId id="262" r:id="rId8"/>
+    <p:sldId id="263" r:id="rId9"/>
+    <p:sldId id="264" r:id="rId10"/>
+    <p:sldId id="265" r:id="rId11"/>
+    <p:sldId id="266" r:id="rId12"/>
+    <p:sldId id="267" r:id="rId13"/>
+    <p:sldId id="268" r:id="rId14"/>
+    <p:sldId id="269" r:id="rId15"/>
+    <p:sldId id="270" r:id="rId16"/>
+    <p:sldId id="271" r:id="rId17"/>
+    <p:sldId id="272" r:id="rId18"/>
   </p:sldIdLst>
-  <p:sldSz cx="12191695" cy="6858000" type="screen4x3"/>
+  <p:sldSz cx="12192000" cy="6858000"/>
   <p:notesSz cx="6858000" cy="9144000"/>
   <p:defaultTextStyle>
     <a:defPPr>
@@ -120,6 +120,22 @@
       </a:defRPr>
     </a:lvl9pPr>
   </p:defaultTextStyle>
+  <p:extLst>
+    <p:ext uri="{EFAFB233-063F-42B5-8137-9DF3F51BA10A}">
+      <p15:sldGuideLst xmlns:p15="http://schemas.microsoft.com/office/powerpoint/2012/main">
+        <p15:guide id="1" orient="horz" pos="2160">
+          <p15:clr>
+            <a:srgbClr val="A4A3A4"/>
+          </p15:clr>
+        </p15:guide>
+        <p15:guide id="2" pos="2880">
+          <p15:clr>
+            <a:srgbClr val="A4A3A4"/>
+          </p15:clr>
+        </p15:guide>
+      </p15:sldGuideLst>
+    </p:ext>
+  </p:extLst>
 </p:presentation>
 </file>
 
@@ -161,10 +177,9 @@
           <a:lstStyle/>
           <a:p>
             <a:r>
-              <a:rPr lang="en-US" smtClean="0"/>
+              <a:rPr lang="en-US"/>
               <a:t>Click to edit Master title style</a:t>
             </a:r>
-            <a:endParaRPr lang="en-US"/>
           </a:p>
         </p:txBody>
       </p:sp>
@@ -280,10 +295,9 @@
           </a:lstStyle>
           <a:p>
             <a:r>
-              <a:rPr lang="en-US" smtClean="0"/>
+              <a:rPr lang="en-US"/>
               <a:t>Click to edit Master subtitle style</a:t>
             </a:r>
-            <a:endParaRPr lang="en-US"/>
           </a:p>
         </p:txBody>
       </p:sp>
@@ -304,7 +318,7 @@
           <a:p>
             <a:fld id="{5BCAD085-E8A6-8845-BD4E-CB4CCA059FC4}" type="datetimeFigureOut">
               <a:rPr lang="en-US" smtClean="0"/>
-              <a:t>1/27/13</a:t>
+              <a:t>5/27/2026</a:t>
             </a:fld>
             <a:endParaRPr lang="en-US"/>
           </a:p>
@@ -346,7 +360,7 @@
           <a:p>
             <a:fld id="{C1FF6DA9-008F-8B48-92A6-B652298478BF}" type="slidenum">
               <a:rPr lang="en-US" smtClean="0"/>
-              <a:t>‹#›</a:t>
+              <a:t>‹nº›</a:t>
             </a:fld>
             <a:endParaRPr lang="en-US"/>
           </a:p>
@@ -398,10 +412,9 @@
           <a:lstStyle/>
           <a:p>
             <a:r>
-              <a:rPr lang="en-US" smtClean="0"/>
+              <a:rPr lang="en-US"/>
               <a:t>Click to edit Master title style</a:t>
             </a:r>
-            <a:endParaRPr lang="en-US"/>
           </a:p>
         </p:txBody>
       </p:sp>
@@ -422,38 +435,37 @@
           <a:p>
             <a:pPr lvl="0"/>
             <a:r>
-              <a:rPr lang="en-US" smtClean="0"/>
+              <a:rPr lang="en-US"/>
               <a:t>Click to edit Master text styles</a:t>
             </a:r>
           </a:p>
           <a:p>
             <a:pPr lvl="1"/>
             <a:r>
-              <a:rPr lang="en-US" smtClean="0"/>
+              <a:rPr lang="en-US"/>
               <a:t>Second level</a:t>
             </a:r>
           </a:p>
           <a:p>
             <a:pPr lvl="2"/>
             <a:r>
-              <a:rPr lang="en-US" smtClean="0"/>
+              <a:rPr lang="en-US"/>
               <a:t>Third level</a:t>
             </a:r>
           </a:p>
           <a:p>
             <a:pPr lvl="3"/>
             <a:r>
-              <a:rPr lang="en-US" smtClean="0"/>
+              <a:rPr lang="en-US"/>
               <a:t>Fourth level</a:t>
             </a:r>
           </a:p>
           <a:p>
             <a:pPr lvl="4"/>
             <a:r>
-              <a:rPr lang="en-US" smtClean="0"/>
+              <a:rPr lang="en-US"/>
               <a:t>Fifth level</a:t>
             </a:r>
-            <a:endParaRPr lang="en-US"/>
           </a:p>
         </p:txBody>
       </p:sp>
@@ -474,7 +486,7 @@
           <a:p>
             <a:fld id="{5BCAD085-E8A6-8845-BD4E-CB4CCA059FC4}" type="datetimeFigureOut">
               <a:rPr lang="en-US" smtClean="0"/>
-              <a:t>1/27/13</a:t>
+              <a:t>5/27/2026</a:t>
             </a:fld>
             <a:endParaRPr lang="en-US"/>
           </a:p>
@@ -516,7 +528,7 @@
           <a:p>
             <a:fld id="{C1FF6DA9-008F-8B48-92A6-B652298478BF}" type="slidenum">
               <a:rPr lang="en-US" smtClean="0"/>
-              <a:t>‹#›</a:t>
+              <a:t>‹nº›</a:t>
             </a:fld>
             <a:endParaRPr lang="en-US"/>
           </a:p>
@@ -573,10 +585,9 @@
           <a:lstStyle/>
           <a:p>
             <a:r>
-              <a:rPr lang="en-US" smtClean="0"/>
+              <a:rPr lang="en-US"/>
               <a:t>Click to edit Master title style</a:t>
             </a:r>
-            <a:endParaRPr lang="en-US"/>
           </a:p>
         </p:txBody>
       </p:sp>
@@ -602,38 +613,37 @@
           <a:p>
             <a:pPr lvl="0"/>
             <a:r>
-              <a:rPr lang="en-US" smtClean="0"/>
+              <a:rPr lang="en-US"/>
               <a:t>Click to edit Master text styles</a:t>
             </a:r>
           </a:p>
           <a:p>
             <a:pPr lvl="1"/>
             <a:r>
-              <a:rPr lang="en-US" smtClean="0"/>
+              <a:rPr lang="en-US"/>
               <a:t>Second level</a:t>
             </a:r>
           </a:p>
           <a:p>
             <a:pPr lvl="2"/>
             <a:r>
-              <a:rPr lang="en-US" smtClean="0"/>
+              <a:rPr lang="en-US"/>
               <a:t>Third level</a:t>
             </a:r>
           </a:p>
           <a:p>
             <a:pPr lvl="3"/>
             <a:r>
-              <a:rPr lang="en-US" smtClean="0"/>
+              <a:rPr lang="en-US"/>
               <a:t>Fourth level</a:t>
             </a:r>
           </a:p>
           <a:p>
             <a:pPr lvl="4"/>
             <a:r>
-              <a:rPr lang="en-US" smtClean="0"/>
+              <a:rPr lang="en-US"/>
               <a:t>Fifth level</a:t>
             </a:r>
-            <a:endParaRPr lang="en-US"/>
           </a:p>
         </p:txBody>
       </p:sp>
@@ -654,7 +664,7 @@
           <a:p>
             <a:fld id="{5BCAD085-E8A6-8845-BD4E-CB4CCA059FC4}" type="datetimeFigureOut">
               <a:rPr lang="en-US" smtClean="0"/>
-              <a:t>1/27/13</a:t>
+              <a:t>5/27/2026</a:t>
             </a:fld>
             <a:endParaRPr lang="en-US"/>
           </a:p>
@@ -696,7 +706,7 @@
           <a:p>
             <a:fld id="{C1FF6DA9-008F-8B48-92A6-B652298478BF}" type="slidenum">
               <a:rPr lang="en-US" smtClean="0"/>
-              <a:t>‹#›</a:t>
+              <a:t>‹nº›</a:t>
             </a:fld>
             <a:endParaRPr lang="en-US"/>
           </a:p>
@@ -748,10 +758,9 @@
           <a:lstStyle/>
           <a:p>
             <a:r>
-              <a:rPr lang="en-US" smtClean="0"/>
+              <a:rPr lang="en-US"/>
               <a:t>Click to edit Master title style</a:t>
             </a:r>
-            <a:endParaRPr lang="en-US"/>
           </a:p>
         </p:txBody>
       </p:sp>
@@ -772,38 +781,37 @@
           <a:p>
             <a:pPr lvl="0"/>
             <a:r>
-              <a:rPr lang="en-US" smtClean="0"/>
+              <a:rPr lang="en-US"/>
               <a:t>Click to edit Master text styles</a:t>
             </a:r>
           </a:p>
           <a:p>
             <a:pPr lvl="1"/>
             <a:r>
-              <a:rPr lang="en-US" smtClean="0"/>
+              <a:rPr lang="en-US"/>
               <a:t>Second level</a:t>
             </a:r>
           </a:p>
           <a:p>
             <a:pPr lvl="2"/>
             <a:r>
-              <a:rPr lang="en-US" smtClean="0"/>
+              <a:rPr lang="en-US"/>
               <a:t>Third level</a:t>
             </a:r>
           </a:p>
           <a:p>
             <a:pPr lvl="3"/>
             <a:r>
-              <a:rPr lang="en-US" smtClean="0"/>
+              <a:rPr lang="en-US"/>
               <a:t>Fourth level</a:t>
             </a:r>
           </a:p>
           <a:p>
             <a:pPr lvl="4"/>
             <a:r>
-              <a:rPr lang="en-US" smtClean="0"/>
+              <a:rPr lang="en-US"/>
               <a:t>Fifth level</a:t>
             </a:r>
-            <a:endParaRPr lang="en-US"/>
           </a:p>
         </p:txBody>
       </p:sp>
@@ -824,7 +832,7 @@
           <a:p>
             <a:fld id="{5BCAD085-E8A6-8845-BD4E-CB4CCA059FC4}" type="datetimeFigureOut">
               <a:rPr lang="en-US" smtClean="0"/>
-              <a:t>1/27/13</a:t>
+              <a:t>5/27/2026</a:t>
             </a:fld>
             <a:endParaRPr lang="en-US"/>
           </a:p>
@@ -866,7 +874,7 @@
           <a:p>
             <a:fld id="{C1FF6DA9-008F-8B48-92A6-B652298478BF}" type="slidenum">
               <a:rPr lang="en-US" smtClean="0"/>
-              <a:t>‹#›</a:t>
+              <a:t>‹nº›</a:t>
             </a:fld>
             <a:endParaRPr lang="en-US"/>
           </a:p>
@@ -927,10 +935,9 @@
           </a:lstStyle>
           <a:p>
             <a:r>
-              <a:rPr lang="en-US" smtClean="0"/>
+              <a:rPr lang="en-US"/>
               <a:t>Click to edit Master title style</a:t>
             </a:r>
-            <a:endParaRPr lang="en-US"/>
           </a:p>
         </p:txBody>
       </p:sp>
@@ -1047,7 +1054,7 @@
           <a:p>
             <a:pPr lvl="0"/>
             <a:r>
-              <a:rPr lang="en-US" smtClean="0"/>
+              <a:rPr lang="en-US"/>
               <a:t>Click to edit Master text styles</a:t>
             </a:r>
           </a:p>
@@ -1070,7 +1077,7 @@
           <a:p>
             <a:fld id="{5BCAD085-E8A6-8845-BD4E-CB4CCA059FC4}" type="datetimeFigureOut">
               <a:rPr lang="en-US" smtClean="0"/>
-              <a:t>1/27/13</a:t>
+              <a:t>5/27/2026</a:t>
             </a:fld>
             <a:endParaRPr lang="en-US"/>
           </a:p>
@@ -1112,7 +1119,7 @@
           <a:p>
             <a:fld id="{C1FF6DA9-008F-8B48-92A6-B652298478BF}" type="slidenum">
               <a:rPr lang="en-US" smtClean="0"/>
-              <a:t>‹#›</a:t>
+              <a:t>‹nº›</a:t>
             </a:fld>
             <a:endParaRPr lang="en-US"/>
           </a:p>
@@ -1164,10 +1171,9 @@
           <a:lstStyle/>
           <a:p>
             <a:r>
-              <a:rPr lang="en-US" smtClean="0"/>
+              <a:rPr lang="en-US"/>
               <a:t>Click to edit Master title style</a:t>
             </a:r>
-            <a:endParaRPr lang="en-US"/>
           </a:p>
         </p:txBody>
       </p:sp>
@@ -1221,38 +1227,37 @@
           <a:p>
             <a:pPr lvl="0"/>
             <a:r>
-              <a:rPr lang="en-US" smtClean="0"/>
+              <a:rPr lang="en-US"/>
               <a:t>Click to edit Master text styles</a:t>
             </a:r>
           </a:p>
           <a:p>
             <a:pPr lvl="1"/>
             <a:r>
-              <a:rPr lang="en-US" smtClean="0"/>
+              <a:rPr lang="en-US"/>
               <a:t>Second level</a:t>
             </a:r>
           </a:p>
           <a:p>
             <a:pPr lvl="2"/>
             <a:r>
-              <a:rPr lang="en-US" smtClean="0"/>
+              <a:rPr lang="en-US"/>
               <a:t>Third level</a:t>
             </a:r>
           </a:p>
           <a:p>
             <a:pPr lvl="3"/>
             <a:r>
-              <a:rPr lang="en-US" smtClean="0"/>
+              <a:rPr lang="en-US"/>
               <a:t>Fourth level</a:t>
             </a:r>
           </a:p>
           <a:p>
             <a:pPr lvl="4"/>
             <a:r>
-              <a:rPr lang="en-US" smtClean="0"/>
+              <a:rPr lang="en-US"/>
               <a:t>Fifth level</a:t>
             </a:r>
-            <a:endParaRPr lang="en-US"/>
           </a:p>
         </p:txBody>
       </p:sp>
@@ -1306,38 +1311,37 @@
           <a:p>
             <a:pPr lvl="0"/>
             <a:r>
-              <a:rPr lang="en-US" smtClean="0"/>
+              <a:rPr lang="en-US"/>
               <a:t>Click to edit Master text styles</a:t>
             </a:r>
           </a:p>
           <a:p>
             <a:pPr lvl="1"/>
             <a:r>
-              <a:rPr lang="en-US" smtClean="0"/>
+              <a:rPr lang="en-US"/>
               <a:t>Second level</a:t>
             </a:r>
           </a:p>
           <a:p>
             <a:pPr lvl="2"/>
             <a:r>
-              <a:rPr lang="en-US" smtClean="0"/>
+              <a:rPr lang="en-US"/>
               <a:t>Third level</a:t>
             </a:r>
           </a:p>
           <a:p>
             <a:pPr lvl="3"/>
             <a:r>
-              <a:rPr lang="en-US" smtClean="0"/>
+              <a:rPr lang="en-US"/>
               <a:t>Fourth level</a:t>
             </a:r>
           </a:p>
           <a:p>
             <a:pPr lvl="4"/>
             <a:r>
-              <a:rPr lang="en-US" smtClean="0"/>
+              <a:rPr lang="en-US"/>
               <a:t>Fifth level</a:t>
             </a:r>
-            <a:endParaRPr lang="en-US"/>
           </a:p>
         </p:txBody>
       </p:sp>
@@ -1358,7 +1362,7 @@
           <a:p>
             <a:fld id="{5BCAD085-E8A6-8845-BD4E-CB4CCA059FC4}" type="datetimeFigureOut">
               <a:rPr lang="en-US" smtClean="0"/>
-              <a:t>1/27/13</a:t>
+              <a:t>5/27/2026</a:t>
             </a:fld>
             <a:endParaRPr lang="en-US"/>
           </a:p>
@@ -1400,7 +1404,7 @@
           <a:p>
             <a:fld id="{C1FF6DA9-008F-8B48-92A6-B652298478BF}" type="slidenum">
               <a:rPr lang="en-US" smtClean="0"/>
-              <a:t>‹#›</a:t>
+              <a:t>‹nº›</a:t>
             </a:fld>
             <a:endParaRPr lang="en-US"/>
           </a:p>
@@ -1456,10 +1460,9 @@
           </a:lstStyle>
           <a:p>
             <a:r>
-              <a:rPr lang="en-US" smtClean="0"/>
+              <a:rPr lang="en-US"/>
               <a:t>Click to edit Master title style</a:t>
             </a:r>
-            <a:endParaRPr lang="en-US"/>
           </a:p>
         </p:txBody>
       </p:sp>
@@ -1522,7 +1525,7 @@
           <a:p>
             <a:pPr lvl="0"/>
             <a:r>
-              <a:rPr lang="en-US" smtClean="0"/>
+              <a:rPr lang="en-US"/>
               <a:t>Click to edit Master text styles</a:t>
             </a:r>
           </a:p>
@@ -1578,38 +1581,37 @@
           <a:p>
             <a:pPr lvl="0"/>
             <a:r>
-              <a:rPr lang="en-US" smtClean="0"/>
+              <a:rPr lang="en-US"/>
               <a:t>Click to edit Master text styles</a:t>
             </a:r>
           </a:p>
           <a:p>
             <a:pPr lvl="1"/>
             <a:r>
-              <a:rPr lang="en-US" smtClean="0"/>
+              <a:rPr lang="en-US"/>
               <a:t>Second level</a:t>
             </a:r>
           </a:p>
           <a:p>
             <a:pPr lvl="2"/>
             <a:r>
-              <a:rPr lang="en-US" smtClean="0"/>
+              <a:rPr lang="en-US"/>
               <a:t>Third level</a:t>
             </a:r>
           </a:p>
           <a:p>
             <a:pPr lvl="3"/>
             <a:r>
-              <a:rPr lang="en-US" smtClean="0"/>
+              <a:rPr lang="en-US"/>
               <a:t>Fourth level</a:t>
             </a:r>
           </a:p>
           <a:p>
             <a:pPr lvl="4"/>
             <a:r>
-              <a:rPr lang="en-US" smtClean="0"/>
+              <a:rPr lang="en-US"/>
               <a:t>Fifth level</a:t>
             </a:r>
-            <a:endParaRPr lang="en-US"/>
           </a:p>
         </p:txBody>
       </p:sp>
@@ -1672,7 +1674,7 @@
           <a:p>
             <a:pPr lvl="0"/>
             <a:r>
-              <a:rPr lang="en-US" smtClean="0"/>
+              <a:rPr lang="en-US"/>
               <a:t>Click to edit Master text styles</a:t>
             </a:r>
           </a:p>
@@ -1728,38 +1730,37 @@
           <a:p>
             <a:pPr lvl="0"/>
             <a:r>
-              <a:rPr lang="en-US" smtClean="0"/>
+              <a:rPr lang="en-US"/>
               <a:t>Click to edit Master text styles</a:t>
             </a:r>
           </a:p>
           <a:p>
             <a:pPr lvl="1"/>
             <a:r>
-              <a:rPr lang="en-US" smtClean="0"/>
+              <a:rPr lang="en-US"/>
               <a:t>Second level</a:t>
             </a:r>
           </a:p>
           <a:p>
             <a:pPr lvl="2"/>
             <a:r>
-              <a:rPr lang="en-US" smtClean="0"/>
+              <a:rPr lang="en-US"/>
               <a:t>Third level</a:t>
             </a:r>
           </a:p>
           <a:p>
             <a:pPr lvl="3"/>
             <a:r>
-              <a:rPr lang="en-US" smtClean="0"/>
+              <a:rPr lang="en-US"/>
               <a:t>Fourth level</a:t>
             </a:r>
           </a:p>
           <a:p>
             <a:pPr lvl="4"/>
             <a:r>
-              <a:rPr lang="en-US" smtClean="0"/>
+              <a:rPr lang="en-US"/>
               <a:t>Fifth level</a:t>
             </a:r>
-            <a:endParaRPr lang="en-US"/>
           </a:p>
         </p:txBody>
       </p:sp>
@@ -1780,7 +1781,7 @@
           <a:p>
             <a:fld id="{5BCAD085-E8A6-8845-BD4E-CB4CCA059FC4}" type="datetimeFigureOut">
               <a:rPr lang="en-US" smtClean="0"/>
-              <a:t>1/27/13</a:t>
+              <a:t>5/27/2026</a:t>
             </a:fld>
             <a:endParaRPr lang="en-US"/>
           </a:p>
@@ -1822,7 +1823,7 @@
           <a:p>
             <a:fld id="{C1FF6DA9-008F-8B48-92A6-B652298478BF}" type="slidenum">
               <a:rPr lang="en-US" smtClean="0"/>
-              <a:t>‹#›</a:t>
+              <a:t>‹nº›</a:t>
             </a:fld>
             <a:endParaRPr lang="en-US"/>
           </a:p>
@@ -1874,10 +1875,9 @@
           <a:lstStyle/>
           <a:p>
             <a:r>
-              <a:rPr lang="en-US" smtClean="0"/>
+              <a:rPr lang="en-US"/>
               <a:t>Click to edit Master title style</a:t>
             </a:r>
-            <a:endParaRPr lang="en-US"/>
           </a:p>
         </p:txBody>
       </p:sp>
@@ -1898,7 +1898,7 @@
           <a:p>
             <a:fld id="{5BCAD085-E8A6-8845-BD4E-CB4CCA059FC4}" type="datetimeFigureOut">
               <a:rPr lang="en-US" smtClean="0"/>
-              <a:t>1/27/13</a:t>
+              <a:t>5/27/2026</a:t>
             </a:fld>
             <a:endParaRPr lang="en-US"/>
           </a:p>
@@ -1940,7 +1940,7 @@
           <a:p>
             <a:fld id="{C1FF6DA9-008F-8B48-92A6-B652298478BF}" type="slidenum">
               <a:rPr lang="en-US" smtClean="0"/>
-              <a:t>‹#›</a:t>
+              <a:t>‹nº›</a:t>
             </a:fld>
             <a:endParaRPr lang="en-US"/>
           </a:p>
@@ -1993,7 +1993,7 @@
           <a:p>
             <a:fld id="{5BCAD085-E8A6-8845-BD4E-CB4CCA059FC4}" type="datetimeFigureOut">
               <a:rPr lang="en-US" smtClean="0"/>
-              <a:t>1/27/13</a:t>
+              <a:t>5/27/2026</a:t>
             </a:fld>
             <a:endParaRPr lang="en-US"/>
           </a:p>
@@ -2035,7 +2035,7 @@
           <a:p>
             <a:fld id="{C1FF6DA9-008F-8B48-92A6-B652298478BF}" type="slidenum">
               <a:rPr lang="en-US" smtClean="0"/>
-              <a:t>‹#›</a:t>
+              <a:t>‹nº›</a:t>
             </a:fld>
             <a:endParaRPr lang="en-US"/>
           </a:p>
@@ -2096,10 +2096,9 @@
           </a:lstStyle>
           <a:p>
             <a:r>
-              <a:rPr lang="en-US" smtClean="0"/>
+              <a:rPr lang="en-US"/>
               <a:t>Click to edit Master title style</a:t>
             </a:r>
-            <a:endParaRPr lang="en-US"/>
           </a:p>
         </p:txBody>
       </p:sp>
@@ -2153,38 +2152,37 @@
           <a:p>
             <a:pPr lvl="0"/>
             <a:r>
-              <a:rPr lang="en-US" smtClean="0"/>
+              <a:rPr lang="en-US"/>
               <a:t>Click to edit Master text styles</a:t>
             </a:r>
           </a:p>
           <a:p>
             <a:pPr lvl="1"/>
             <a:r>
-              <a:rPr lang="en-US" smtClean="0"/>
+              <a:rPr lang="en-US"/>
               <a:t>Second level</a:t>
             </a:r>
           </a:p>
           <a:p>
             <a:pPr lvl="2"/>
             <a:r>
-              <a:rPr lang="en-US" smtClean="0"/>
+              <a:rPr lang="en-US"/>
               <a:t>Third level</a:t>
             </a:r>
           </a:p>
           <a:p>
             <a:pPr lvl="3"/>
             <a:r>
-              <a:rPr lang="en-US" smtClean="0"/>
+              <a:rPr lang="en-US"/>
               <a:t>Fourth level</a:t>
             </a:r>
           </a:p>
           <a:p>
             <a:pPr lvl="4"/>
             <a:r>
-              <a:rPr lang="en-US" smtClean="0"/>
+              <a:rPr lang="en-US"/>
               <a:t>Fifth level</a:t>
             </a:r>
-            <a:endParaRPr lang="en-US"/>
           </a:p>
         </p:txBody>
       </p:sp>
@@ -2247,7 +2245,7 @@
           <a:p>
             <a:pPr lvl="0"/>
             <a:r>
-              <a:rPr lang="en-US" smtClean="0"/>
+              <a:rPr lang="en-US"/>
               <a:t>Click to edit Master text styles</a:t>
             </a:r>
           </a:p>
@@ -2270,7 +2268,7 @@
           <a:p>
             <a:fld id="{5BCAD085-E8A6-8845-BD4E-CB4CCA059FC4}" type="datetimeFigureOut">
               <a:rPr lang="en-US" smtClean="0"/>
-              <a:t>1/27/13</a:t>
+              <a:t>5/27/2026</a:t>
             </a:fld>
             <a:endParaRPr lang="en-US"/>
           </a:p>
@@ -2312,7 +2310,7 @@
           <a:p>
             <a:fld id="{C1FF6DA9-008F-8B48-92A6-B652298478BF}" type="slidenum">
               <a:rPr lang="en-US" smtClean="0"/>
-              <a:t>‹#›</a:t>
+              <a:t>‹nº›</a:t>
             </a:fld>
             <a:endParaRPr lang="en-US"/>
           </a:p>
@@ -2373,10 +2371,9 @@
           </a:lstStyle>
           <a:p>
             <a:r>
-              <a:rPr lang="en-US" smtClean="0"/>
+              <a:rPr lang="en-US"/>
               <a:t>Click to edit Master title style</a:t>
             </a:r>
-            <a:endParaRPr lang="en-US"/>
           </a:p>
         </p:txBody>
       </p:sp>
@@ -2500,7 +2497,7 @@
           <a:p>
             <a:pPr lvl="0"/>
             <a:r>
-              <a:rPr lang="en-US" smtClean="0"/>
+              <a:rPr lang="en-US"/>
               <a:t>Click to edit Master text styles</a:t>
             </a:r>
           </a:p>
@@ -2523,7 +2520,7 @@
           <a:p>
             <a:fld id="{5BCAD085-E8A6-8845-BD4E-CB4CCA059FC4}" type="datetimeFigureOut">
               <a:rPr lang="en-US" smtClean="0"/>
-              <a:t>1/27/13</a:t>
+              <a:t>5/27/2026</a:t>
             </a:fld>
             <a:endParaRPr lang="en-US"/>
           </a:p>
@@ -2565,7 +2562,7 @@
           <a:p>
             <a:fld id="{C1FF6DA9-008F-8B48-92A6-B652298478BF}" type="slidenum">
               <a:rPr lang="en-US" smtClean="0"/>
-              <a:t>‹#›</a:t>
+              <a:t>‹nº›</a:t>
             </a:fld>
             <a:endParaRPr lang="en-US"/>
           </a:p>
@@ -2632,10 +2629,9 @@
           <a:lstStyle/>
           <a:p>
             <a:r>
-              <a:rPr lang="en-US" smtClean="0"/>
+              <a:rPr lang="en-US"/>
               <a:t>Click to edit Master title style</a:t>
             </a:r>
-            <a:endParaRPr lang="en-US"/>
           </a:p>
         </p:txBody>
       </p:sp>
@@ -2666,38 +2662,37 @@
           <a:p>
             <a:pPr lvl="0"/>
             <a:r>
-              <a:rPr lang="en-US" smtClean="0"/>
+              <a:rPr lang="en-US"/>
               <a:t>Click to edit Master text styles</a:t>
             </a:r>
           </a:p>
           <a:p>
             <a:pPr lvl="1"/>
             <a:r>
-              <a:rPr lang="en-US" smtClean="0"/>
+              <a:rPr lang="en-US"/>
               <a:t>Second level</a:t>
             </a:r>
           </a:p>
           <a:p>
             <a:pPr lvl="2"/>
             <a:r>
-              <a:rPr lang="en-US" smtClean="0"/>
+              <a:rPr lang="en-US"/>
               <a:t>Third level</a:t>
             </a:r>
           </a:p>
           <a:p>
             <a:pPr lvl="3"/>
             <a:r>
-              <a:rPr lang="en-US" smtClean="0"/>
+              <a:rPr lang="en-US"/>
               <a:t>Fourth level</a:t>
             </a:r>
           </a:p>
           <a:p>
             <a:pPr lvl="4"/>
             <a:r>
-              <a:rPr lang="en-US" smtClean="0"/>
+              <a:rPr lang="en-US"/>
               <a:t>Fifth level</a:t>
             </a:r>
-            <a:endParaRPr lang="en-US"/>
           </a:p>
         </p:txBody>
       </p:sp>
@@ -2736,7 +2731,7 @@
           <a:p>
             <a:fld id="{5BCAD085-E8A6-8845-BD4E-CB4CCA059FC4}" type="datetimeFigureOut">
               <a:rPr lang="en-US" smtClean="0"/>
-              <a:t>1/27/13</a:t>
+              <a:t>5/27/2026</a:t>
             </a:fld>
             <a:endParaRPr lang="en-US"/>
           </a:p>
@@ -2814,7 +2809,7 @@
           <a:p>
             <a:fld id="{C1FF6DA9-008F-8B48-92A6-B652298478BF}" type="slidenum">
               <a:rPr lang="en-US" smtClean="0"/>
-              <a:t>‹#›</a:t>
+              <a:t>‹nº›</a:t>
             </a:fld>
             <a:endParaRPr lang="en-US"/>
           </a:p>
@@ -3095,7 +3090,7 @@
 </file>
 
 <file path=ppt/slides/slide1.xml><?xml version="1.0" encoding="utf-8"?>
-<p:sld xmlns:a="http://schemas.openxmlformats.org/drawingml/2006/main" xmlns:p="http://schemas.openxmlformats.org/presentationml/2006/main" xmlns:r="http://schemas.openxmlformats.org/officeDocument/2006/relationships">
+<p:sld xmlns:a="http://schemas.openxmlformats.org/drawingml/2006/main" xmlns:r="http://schemas.openxmlformats.org/officeDocument/2006/relationships" xmlns:p="http://schemas.openxmlformats.org/presentationml/2006/main">
   <p:cSld>
     <p:spTree>
       <p:nvGrpSpPr>
@@ -3103,7 +3098,14 @@
         <p:cNvGrpSpPr/>
         <p:nvPr/>
       </p:nvGrpSpPr>
-      <p:grpSpPr/>
+      <p:grpSpPr>
+        <a:xfrm>
+          <a:off x="0" y="0"/>
+          <a:ext cx="0" cy="0"/>
+          <a:chOff x="0" y="0"/>
+          <a:chExt cx="0" cy="0"/>
+        </a:xfrm>
+      </p:grpSpPr>
       <p:sp>
         <p:nvSpPr>
           <p:cNvPr id="2" name="Rectangle 1"/>
@@ -3145,6 +3147,7 @@
           <a:lstStyle/>
           <a:p>
             <a:pPr algn="ctr"/>
+            <a:endParaRPr/>
           </a:p>
         </p:txBody>
       </p:sp>
@@ -3189,6 +3192,7 @@
           <a:lstStyle/>
           <a:p>
             <a:pPr algn="ctr"/>
+            <a:endParaRPr/>
           </a:p>
         </p:txBody>
       </p:sp>
@@ -3233,6 +3237,7 @@
           <a:lstStyle/>
           <a:p>
             <a:pPr algn="ctr"/>
+            <a:endParaRPr/>
           </a:p>
         </p:txBody>
       </p:sp>
@@ -3253,7 +3258,7 @@
           <a:noFill/>
         </p:spPr>
         <p:txBody>
-          <a:bodyPr wrap="square" lIns="0" rIns="0" tIns="0" bIns="0" anchor="t">
+          <a:bodyPr wrap="square" lIns="0" tIns="0" rIns="0" bIns="0" anchor="t">
             <a:spAutoFit/>
           </a:bodyPr>
           <a:lstStyle/>
@@ -3308,7 +3313,7 @@
           </a:fontRef>
         </p:style>
         <p:txBody>
-          <a:bodyPr rtlCol="0" anchor="ctr" lIns="0" rIns="0" tIns="0" bIns="0"/>
+          <a:bodyPr lIns="0" tIns="0" rIns="0" bIns="0" rtlCol="0" anchor="ctr"/>
           <a:lstStyle/>
           <a:p>
             <a:pPr algn="ctr"/>
@@ -3341,7 +3346,7 @@
           <a:noFill/>
         </p:spPr>
         <p:txBody>
-          <a:bodyPr wrap="square" lIns="0" rIns="0" tIns="0" bIns="0" anchor="t">
+          <a:bodyPr wrap="square" lIns="0" tIns="0" rIns="0" bIns="0" anchor="t">
             <a:spAutoFit/>
           </a:bodyPr>
           <a:lstStyle/>
@@ -3376,7 +3381,7 @@
           <a:noFill/>
         </p:spPr>
         <p:txBody>
-          <a:bodyPr wrap="square" lIns="0" rIns="0" tIns="0" bIns="0" anchor="t">
+          <a:bodyPr wrap="square" lIns="0" tIns="0" rIns="0" bIns="0" anchor="t">
             <a:spAutoFit/>
           </a:bodyPr>
           <a:lstStyle/>
@@ -3435,6 +3440,7 @@
           <a:lstStyle/>
           <a:p>
             <a:pPr algn="ctr"/>
+            <a:endParaRPr/>
           </a:p>
         </p:txBody>
       </p:sp>
@@ -3455,7 +3461,7 @@
           <a:noFill/>
         </p:spPr>
         <p:txBody>
-          <a:bodyPr wrap="square" lIns="0" rIns="0" tIns="0" bIns="0" anchor="t">
+          <a:bodyPr wrap="square" lIns="0" tIns="0" rIns="0" bIns="0" anchor="t">
             <a:spAutoFit/>
           </a:bodyPr>
           <a:lstStyle/>
@@ -3532,7 +3538,7 @@
           <a:noFill/>
         </p:spPr>
         <p:txBody>
-          <a:bodyPr wrap="square" lIns="0" rIns="0" tIns="0" bIns="0" anchor="t">
+          <a:bodyPr wrap="square" lIns="0" tIns="0" rIns="0" bIns="0" anchor="t">
             <a:spAutoFit/>
           </a:bodyPr>
           <a:lstStyle/>
@@ -3601,7 +3607,7 @@
 </file>
 
 <file path=ppt/slides/slide10.xml><?xml version="1.0" encoding="utf-8"?>
-<p:sld xmlns:a="http://schemas.openxmlformats.org/drawingml/2006/main" xmlns:p="http://schemas.openxmlformats.org/presentationml/2006/main" xmlns:r="http://schemas.openxmlformats.org/officeDocument/2006/relationships">
+<p:sld xmlns:a="http://schemas.openxmlformats.org/drawingml/2006/main" xmlns:r="http://schemas.openxmlformats.org/officeDocument/2006/relationships" xmlns:p="http://schemas.openxmlformats.org/presentationml/2006/main">
   <p:cSld>
     <p:spTree>
       <p:nvGrpSpPr>
@@ -3609,7 +3615,14 @@
         <p:cNvGrpSpPr/>
         <p:nvPr/>
       </p:nvGrpSpPr>
-      <p:grpSpPr/>
+      <p:grpSpPr>
+        <a:xfrm>
+          <a:off x="0" y="0"/>
+          <a:ext cx="0" cy="0"/>
+          <a:chOff x="0" y="0"/>
+          <a:chExt cx="0" cy="0"/>
+        </a:xfrm>
+      </p:grpSpPr>
       <p:sp>
         <p:nvSpPr>
           <p:cNvPr id="2" name="Rectangle 1"/>
@@ -3651,6 +3664,7 @@
           <a:lstStyle/>
           <a:p>
             <a:pPr algn="ctr"/>
+            <a:endParaRPr/>
           </a:p>
         </p:txBody>
       </p:sp>
@@ -3671,7 +3685,7 @@
           <a:noFill/>
         </p:spPr>
         <p:txBody>
-          <a:bodyPr wrap="square" lIns="0" rIns="0" tIns="0" bIns="0" anchor="t">
+          <a:bodyPr wrap="square" lIns="0" tIns="0" rIns="0" bIns="0" anchor="t">
             <a:spAutoFit/>
           </a:bodyPr>
           <a:lstStyle/>
@@ -3706,7 +3720,7 @@
           <a:noFill/>
         </p:spPr>
         <p:txBody>
-          <a:bodyPr wrap="square" lIns="0" rIns="0" tIns="0" bIns="0" anchor="t">
+          <a:bodyPr wrap="square" lIns="0" tIns="0" rIns="0" bIns="0" anchor="t">
             <a:spAutoFit/>
           </a:bodyPr>
           <a:lstStyle/>
@@ -3741,7 +3755,7 @@
           <a:noFill/>
         </p:spPr>
         <p:txBody>
-          <a:bodyPr wrap="square" lIns="0" rIns="0" tIns="0" bIns="0" anchor="t">
+          <a:bodyPr wrap="square" lIns="0" tIns="0" rIns="0" bIns="0" anchor="t">
             <a:spAutoFit/>
           </a:bodyPr>
           <a:lstStyle/>
@@ -3776,7 +3790,7 @@
           <a:noFill/>
         </p:spPr>
         <p:txBody>
-          <a:bodyPr wrap="square" lIns="0" rIns="0" tIns="0" bIns="0" anchor="t">
+          <a:bodyPr wrap="square" lIns="0" tIns="0" rIns="0" bIns="0" anchor="t">
             <a:spAutoFit/>
           </a:bodyPr>
           <a:lstStyle/>
@@ -3811,7 +3825,7 @@
           <a:noFill/>
         </p:spPr>
         <p:txBody>
-          <a:bodyPr wrap="square" lIns="0" rIns="0" tIns="0" bIns="0" anchor="t">
+          <a:bodyPr wrap="square" lIns="0" tIns="0" rIns="0" bIns="0" anchor="t">
             <a:spAutoFit/>
           </a:bodyPr>
           <a:lstStyle/>
@@ -3846,7 +3860,7 @@
           <a:noFill/>
         </p:spPr>
         <p:txBody>
-          <a:bodyPr wrap="square" lIns="0" rIns="0" tIns="0" bIns="0" anchor="ctr">
+          <a:bodyPr wrap="square" lIns="0" tIns="0" rIns="0" bIns="0" anchor="ctr">
             <a:spAutoFit/>
           </a:bodyPr>
           <a:lstStyle/>
@@ -3905,6 +3919,7 @@
           <a:lstStyle/>
           <a:p>
             <a:pPr algn="ctr"/>
+            <a:endParaRPr/>
           </a:p>
         </p:txBody>
       </p:sp>
@@ -3945,7 +3960,7 @@
           </a:fontRef>
         </p:style>
         <p:txBody>
-          <a:bodyPr rtlCol="0" anchor="ctr" lIns="0" rIns="0" tIns="0" bIns="0"/>
+          <a:bodyPr lIns="0" tIns="0" rIns="0" bIns="0" rtlCol="0" anchor="ctr"/>
           <a:lstStyle/>
           <a:p>
             <a:pPr algn="ctr"/>
@@ -3978,7 +3993,7 @@
           <a:noFill/>
         </p:spPr>
         <p:txBody>
-          <a:bodyPr wrap="square" lIns="0" rIns="0" tIns="0" bIns="0" anchor="t">
+          <a:bodyPr wrap="square" lIns="0" tIns="0" rIns="0" bIns="0" anchor="t">
             <a:spAutoFit/>
           </a:bodyPr>
           <a:lstStyle/>
@@ -4013,7 +4028,7 @@
           <a:noFill/>
         </p:spPr>
         <p:txBody>
-          <a:bodyPr wrap="square" lIns="0" rIns="0" tIns="0" bIns="0" anchor="t">
+          <a:bodyPr wrap="square" lIns="0" tIns="0" rIns="0" bIns="0" anchor="t">
             <a:spAutoFit/>
           </a:bodyPr>
           <a:lstStyle/>
@@ -4068,7 +4083,7 @@
           </a:fontRef>
         </p:style>
         <p:txBody>
-          <a:bodyPr rtlCol="0" anchor="ctr" lIns="0" rIns="0" tIns="0" bIns="0"/>
+          <a:bodyPr lIns="0" tIns="0" rIns="0" bIns="0" rtlCol="0" anchor="ctr"/>
           <a:lstStyle/>
           <a:p>
             <a:pPr algn="ctr"/>
@@ -4101,7 +4116,7 @@
           <a:noFill/>
         </p:spPr>
         <p:txBody>
-          <a:bodyPr wrap="square" lIns="0" rIns="0" tIns="0" bIns="0" anchor="t">
+          <a:bodyPr wrap="square" lIns="0" tIns="0" rIns="0" bIns="0" anchor="t">
             <a:spAutoFit/>
           </a:bodyPr>
           <a:lstStyle/>
@@ -4136,7 +4151,7 @@
           <a:noFill/>
         </p:spPr>
         <p:txBody>
-          <a:bodyPr wrap="square" lIns="0" rIns="0" tIns="0" bIns="0" anchor="t">
+          <a:bodyPr wrap="square" lIns="0" tIns="0" rIns="0" bIns="0" anchor="t">
             <a:spAutoFit/>
           </a:bodyPr>
           <a:lstStyle/>
@@ -4191,7 +4206,7 @@
           </a:fontRef>
         </p:style>
         <p:txBody>
-          <a:bodyPr rtlCol="0" anchor="ctr" lIns="0" rIns="0" tIns="0" bIns="0"/>
+          <a:bodyPr lIns="0" tIns="0" rIns="0" bIns="0" rtlCol="0" anchor="ctr"/>
           <a:lstStyle/>
           <a:p>
             <a:pPr algn="ctr"/>
@@ -4224,7 +4239,7 @@
           <a:noFill/>
         </p:spPr>
         <p:txBody>
-          <a:bodyPr wrap="square" lIns="0" rIns="0" tIns="0" bIns="0" anchor="t">
+          <a:bodyPr wrap="square" lIns="0" tIns="0" rIns="0" bIns="0" anchor="t">
             <a:spAutoFit/>
           </a:bodyPr>
           <a:lstStyle/>
@@ -4259,7 +4274,7 @@
           <a:noFill/>
         </p:spPr>
         <p:txBody>
-          <a:bodyPr wrap="square" lIns="0" rIns="0" tIns="0" bIns="0" anchor="t">
+          <a:bodyPr wrap="square" lIns="0" tIns="0" rIns="0" bIns="0" anchor="t">
             <a:spAutoFit/>
           </a:bodyPr>
           <a:lstStyle/>
@@ -4318,6 +4333,7 @@
           <a:lstStyle/>
           <a:p>
             <a:pPr algn="ctr"/>
+            <a:endParaRPr/>
           </a:p>
         </p:txBody>
       </p:sp>
@@ -4362,6 +4378,7 @@
           <a:lstStyle/>
           <a:p>
             <a:pPr algn="ctr"/>
+            <a:endParaRPr/>
           </a:p>
         </p:txBody>
       </p:sp>
@@ -4382,7 +4399,7 @@
           <a:noFill/>
         </p:spPr>
         <p:txBody>
-          <a:bodyPr wrap="square" lIns="0" rIns="0" tIns="0" bIns="0" anchor="t">
+          <a:bodyPr wrap="square" lIns="0" tIns="0" rIns="0" bIns="0" anchor="t">
             <a:spAutoFit/>
           </a:bodyPr>
           <a:lstStyle/>
@@ -4409,7 +4426,7 @@
 </file>
 
 <file path=ppt/slides/slide11.xml><?xml version="1.0" encoding="utf-8"?>
-<p:sld xmlns:a="http://schemas.openxmlformats.org/drawingml/2006/main" xmlns:p="http://schemas.openxmlformats.org/presentationml/2006/main" xmlns:r="http://schemas.openxmlformats.org/officeDocument/2006/relationships">
+<p:sld xmlns:a="http://schemas.openxmlformats.org/drawingml/2006/main" xmlns:r="http://schemas.openxmlformats.org/officeDocument/2006/relationships" xmlns:p="http://schemas.openxmlformats.org/presentationml/2006/main">
   <p:cSld>
     <p:spTree>
       <p:nvGrpSpPr>
@@ -4417,7 +4434,14 @@
         <p:cNvGrpSpPr/>
         <p:nvPr/>
       </p:nvGrpSpPr>
-      <p:grpSpPr/>
+      <p:grpSpPr>
+        <a:xfrm>
+          <a:off x="0" y="0"/>
+          <a:ext cx="0" cy="0"/>
+          <a:chOff x="0" y="0"/>
+          <a:chExt cx="0" cy="0"/>
+        </a:xfrm>
+      </p:grpSpPr>
       <p:sp>
         <p:nvSpPr>
           <p:cNvPr id="2" name="Rectangle 1"/>
@@ -4459,6 +4483,7 @@
           <a:lstStyle/>
           <a:p>
             <a:pPr algn="ctr"/>
+            <a:endParaRPr/>
           </a:p>
         </p:txBody>
       </p:sp>
@@ -4503,6 +4528,7 @@
           <a:lstStyle/>
           <a:p>
             <a:pPr algn="ctr"/>
+            <a:endParaRPr/>
           </a:p>
         </p:txBody>
       </p:sp>
@@ -4523,7 +4549,7 @@
           <a:noFill/>
         </p:spPr>
         <p:txBody>
-          <a:bodyPr wrap="square" lIns="0" rIns="0" tIns="0" bIns="0" anchor="t">
+          <a:bodyPr wrap="square" lIns="0" tIns="0" rIns="0" bIns="0" anchor="t">
             <a:spAutoFit/>
           </a:bodyPr>
           <a:lstStyle/>
@@ -4558,7 +4584,7 @@
           <a:noFill/>
         </p:spPr>
         <p:txBody>
-          <a:bodyPr wrap="square" lIns="0" rIns="0" tIns="0" bIns="0" anchor="t">
+          <a:bodyPr wrap="square" lIns="0" tIns="0" rIns="0" bIns="0" anchor="t">
             <a:spAutoFit/>
           </a:bodyPr>
           <a:lstStyle/>
@@ -4593,7 +4619,7 @@
           <a:noFill/>
         </p:spPr>
         <p:txBody>
-          <a:bodyPr wrap="square" lIns="0" rIns="0" tIns="0" bIns="0" anchor="t">
+          <a:bodyPr wrap="square" lIns="0" tIns="0" rIns="0" bIns="0" anchor="t">
             <a:spAutoFit/>
           </a:bodyPr>
           <a:lstStyle/>
@@ -4628,7 +4654,7 @@
           <a:noFill/>
         </p:spPr>
         <p:txBody>
-          <a:bodyPr wrap="square" lIns="0" rIns="0" tIns="0" bIns="0" anchor="t">
+          <a:bodyPr wrap="square" lIns="0" tIns="0" rIns="0" bIns="0" anchor="t">
             <a:spAutoFit/>
           </a:bodyPr>
           <a:lstStyle/>
@@ -4663,7 +4689,7 @@
           <a:noFill/>
         </p:spPr>
         <p:txBody>
-          <a:bodyPr wrap="square" lIns="0" rIns="0" tIns="0" bIns="0" anchor="t">
+          <a:bodyPr wrap="square" lIns="0" tIns="0" rIns="0" bIns="0" anchor="t">
             <a:spAutoFit/>
           </a:bodyPr>
           <a:lstStyle/>
@@ -4718,7 +4744,7 @@
           </a:fontRef>
         </p:style>
         <p:txBody>
-          <a:bodyPr rtlCol="0" anchor="ctr" lIns="0" rIns="0" tIns="0" bIns="0"/>
+          <a:bodyPr lIns="0" tIns="0" rIns="0" bIns="0" rtlCol="0" anchor="ctr"/>
           <a:lstStyle/>
           <a:p>
             <a:pPr algn="ctr"/>
@@ -4771,7 +4797,7 @@
           </a:fontRef>
         </p:style>
         <p:txBody>
-          <a:bodyPr rtlCol="0" anchor="ctr" lIns="0" rIns="0" tIns="0" bIns="0"/>
+          <a:bodyPr lIns="0" tIns="0" rIns="0" bIns="0" rtlCol="0" anchor="ctr"/>
           <a:lstStyle/>
           <a:p>
             <a:pPr algn="ctr"/>
@@ -4804,7 +4830,7 @@
           <a:noFill/>
         </p:spPr>
         <p:txBody>
-          <a:bodyPr wrap="square" lIns="0" rIns="0" tIns="0" bIns="0" anchor="t">
+          <a:bodyPr wrap="square" lIns="0" tIns="0" rIns="0" bIns="0" anchor="t">
             <a:spAutoFit/>
           </a:bodyPr>
           <a:lstStyle/>
@@ -4839,7 +4865,7 @@
           <a:noFill/>
         </p:spPr>
         <p:txBody>
-          <a:bodyPr wrap="square" lIns="0" rIns="0" tIns="0" bIns="0" anchor="t">
+          <a:bodyPr wrap="square" lIns="0" tIns="0" rIns="0" bIns="0" anchor="t">
             <a:spAutoFit/>
           </a:bodyPr>
           <a:lstStyle/>
@@ -4980,6 +5006,7 @@
           <a:lstStyle/>
           <a:p>
             <a:pPr algn="ctr"/>
+            <a:endParaRPr/>
           </a:p>
         </p:txBody>
       </p:sp>
@@ -5000,7 +5027,7 @@
           <a:noFill/>
         </p:spPr>
         <p:txBody>
-          <a:bodyPr wrap="square" lIns="0" rIns="0" tIns="0" bIns="0" anchor="t">
+          <a:bodyPr wrap="square" lIns="0" tIns="0" rIns="0" bIns="0" anchor="t">
             <a:spAutoFit/>
           </a:bodyPr>
           <a:lstStyle/>
@@ -5050,7 +5077,7 @@
 </file>
 
 <file path=ppt/slides/slide12.xml><?xml version="1.0" encoding="utf-8"?>
-<p:sld xmlns:a="http://schemas.openxmlformats.org/drawingml/2006/main" xmlns:p="http://schemas.openxmlformats.org/presentationml/2006/main" xmlns:r="http://schemas.openxmlformats.org/officeDocument/2006/relationships">
+<p:sld xmlns:a="http://schemas.openxmlformats.org/drawingml/2006/main" xmlns:r="http://schemas.openxmlformats.org/officeDocument/2006/relationships" xmlns:p="http://schemas.openxmlformats.org/presentationml/2006/main">
   <p:cSld>
     <p:spTree>
       <p:nvGrpSpPr>
@@ -5058,7 +5085,14 @@
         <p:cNvGrpSpPr/>
         <p:nvPr/>
       </p:nvGrpSpPr>
-      <p:grpSpPr/>
+      <p:grpSpPr>
+        <a:xfrm>
+          <a:off x="0" y="0"/>
+          <a:ext cx="0" cy="0"/>
+          <a:chOff x="0" y="0"/>
+          <a:chExt cx="0" cy="0"/>
+        </a:xfrm>
+      </p:grpSpPr>
       <p:sp>
         <p:nvSpPr>
           <p:cNvPr id="2" name="Rectangle 1"/>
@@ -5100,6 +5134,7 @@
           <a:lstStyle/>
           <a:p>
             <a:pPr algn="ctr"/>
+            <a:endParaRPr/>
           </a:p>
         </p:txBody>
       </p:sp>
@@ -5120,7 +5155,7 @@
           <a:noFill/>
         </p:spPr>
         <p:txBody>
-          <a:bodyPr wrap="square" lIns="0" rIns="0" tIns="0" bIns="0" anchor="t">
+          <a:bodyPr wrap="square" lIns="0" tIns="0" rIns="0" bIns="0" anchor="t">
             <a:spAutoFit/>
           </a:bodyPr>
           <a:lstStyle/>
@@ -5155,7 +5190,7 @@
           <a:noFill/>
         </p:spPr>
         <p:txBody>
-          <a:bodyPr wrap="square" lIns="0" rIns="0" tIns="0" bIns="0" anchor="t">
+          <a:bodyPr wrap="square" lIns="0" tIns="0" rIns="0" bIns="0" anchor="t">
             <a:spAutoFit/>
           </a:bodyPr>
           <a:lstStyle/>
@@ -5190,7 +5225,7 @@
           <a:noFill/>
         </p:spPr>
         <p:txBody>
-          <a:bodyPr wrap="square" lIns="0" rIns="0" tIns="0" bIns="0" anchor="t">
+          <a:bodyPr wrap="square" lIns="0" tIns="0" rIns="0" bIns="0" anchor="t">
             <a:spAutoFit/>
           </a:bodyPr>
           <a:lstStyle/>
@@ -5225,7 +5260,7 @@
           <a:noFill/>
         </p:spPr>
         <p:txBody>
-          <a:bodyPr wrap="square" lIns="0" rIns="0" tIns="0" bIns="0" anchor="t">
+          <a:bodyPr wrap="square" lIns="0" tIns="0" rIns="0" bIns="0" anchor="t">
             <a:spAutoFit/>
           </a:bodyPr>
           <a:lstStyle/>
@@ -5260,7 +5295,7 @@
           <a:noFill/>
         </p:spPr>
         <p:txBody>
-          <a:bodyPr wrap="square" lIns="0" rIns="0" tIns="0" bIns="0" anchor="t">
+          <a:bodyPr wrap="square" lIns="0" tIns="0" rIns="0" bIns="0" anchor="t">
             <a:spAutoFit/>
           </a:bodyPr>
           <a:lstStyle/>
@@ -5295,7 +5330,7 @@
           <a:noFill/>
         </p:spPr>
         <p:txBody>
-          <a:bodyPr wrap="square" lIns="0" rIns="0" tIns="0" bIns="0" anchor="ctr">
+          <a:bodyPr wrap="square" lIns="0" tIns="0" rIns="0" bIns="0" anchor="ctr">
             <a:spAutoFit/>
           </a:bodyPr>
           <a:lstStyle/>
@@ -5354,6 +5389,7 @@
           <a:lstStyle/>
           <a:p>
             <a:pPr algn="ctr"/>
+            <a:endParaRPr/>
           </a:p>
         </p:txBody>
       </p:sp>
@@ -5374,7 +5410,7 @@
           <a:noFill/>
         </p:spPr>
         <p:txBody>
-          <a:bodyPr wrap="square" lIns="0" rIns="0" tIns="0" bIns="0" anchor="t">
+          <a:bodyPr wrap="square" lIns="0" tIns="0" rIns="0" bIns="0" anchor="t">
             <a:spAutoFit/>
           </a:bodyPr>
           <a:lstStyle/>
@@ -5433,6 +5469,7 @@
           <a:lstStyle/>
           <a:p>
             <a:pPr algn="ctr"/>
+            <a:endParaRPr/>
           </a:p>
         </p:txBody>
       </p:sp>
@@ -5453,7 +5490,7 @@
           <a:noFill/>
         </p:spPr>
         <p:txBody>
-          <a:bodyPr wrap="square" lIns="0" rIns="0" tIns="0" bIns="0" anchor="t">
+          <a:bodyPr wrap="square" lIns="0" tIns="0" rIns="0" bIns="0" anchor="t">
             <a:spAutoFit/>
           </a:bodyPr>
           <a:lstStyle/>
@@ -5519,6 +5556,7 @@
           <a:lstStyle/>
           <a:p>
             <a:pPr algn="ctr"/>
+            <a:endParaRPr/>
           </a:p>
         </p:txBody>
       </p:sp>
@@ -5563,6 +5601,7 @@
           <a:lstStyle/>
           <a:p>
             <a:pPr algn="ctr"/>
+            <a:endParaRPr/>
           </a:p>
         </p:txBody>
       </p:sp>
@@ -5583,7 +5622,7 @@
           <a:noFill/>
         </p:spPr>
         <p:txBody>
-          <a:bodyPr wrap="square" lIns="0" rIns="0" tIns="0" bIns="0" anchor="t">
+          <a:bodyPr wrap="square" lIns="0" tIns="0" rIns="0" bIns="0" anchor="t">
             <a:spAutoFit/>
           </a:bodyPr>
           <a:lstStyle/>
@@ -5610,7 +5649,7 @@
 </file>
 
 <file path=ppt/slides/slide13.xml><?xml version="1.0" encoding="utf-8"?>
-<p:sld xmlns:a="http://schemas.openxmlformats.org/drawingml/2006/main" xmlns:p="http://schemas.openxmlformats.org/presentationml/2006/main" xmlns:r="http://schemas.openxmlformats.org/officeDocument/2006/relationships">
+<p:sld xmlns:a="http://schemas.openxmlformats.org/drawingml/2006/main" xmlns:r="http://schemas.openxmlformats.org/officeDocument/2006/relationships" xmlns:p="http://schemas.openxmlformats.org/presentationml/2006/main">
   <p:cSld>
     <p:spTree>
       <p:nvGrpSpPr>
@@ -5618,7 +5657,14 @@
         <p:cNvGrpSpPr/>
         <p:nvPr/>
       </p:nvGrpSpPr>
-      <p:grpSpPr/>
+      <p:grpSpPr>
+        <a:xfrm>
+          <a:off x="0" y="0"/>
+          <a:ext cx="0" cy="0"/>
+          <a:chOff x="0" y="0"/>
+          <a:chExt cx="0" cy="0"/>
+        </a:xfrm>
+      </p:grpSpPr>
       <p:sp>
         <p:nvSpPr>
           <p:cNvPr id="2" name="Rectangle 1"/>
@@ -5660,6 +5706,7 @@
           <a:lstStyle/>
           <a:p>
             <a:pPr algn="ctr"/>
+            <a:endParaRPr/>
           </a:p>
         </p:txBody>
       </p:sp>
@@ -5704,6 +5751,7 @@
           <a:lstStyle/>
           <a:p>
             <a:pPr algn="ctr"/>
+            <a:endParaRPr/>
           </a:p>
         </p:txBody>
       </p:sp>
@@ -5724,7 +5772,7 @@
           <a:noFill/>
         </p:spPr>
         <p:txBody>
-          <a:bodyPr wrap="square" lIns="0" rIns="0" tIns="0" bIns="0" anchor="t">
+          <a:bodyPr wrap="square" lIns="0" tIns="0" rIns="0" bIns="0" anchor="t">
             <a:spAutoFit/>
           </a:bodyPr>
           <a:lstStyle/>
@@ -5759,7 +5807,7 @@
           <a:noFill/>
         </p:spPr>
         <p:txBody>
-          <a:bodyPr wrap="square" lIns="0" rIns="0" tIns="0" bIns="0" anchor="t">
+          <a:bodyPr wrap="square" lIns="0" tIns="0" rIns="0" bIns="0" anchor="t">
             <a:spAutoFit/>
           </a:bodyPr>
           <a:lstStyle/>
@@ -5794,7 +5842,7 @@
           <a:noFill/>
         </p:spPr>
         <p:txBody>
-          <a:bodyPr wrap="square" lIns="0" rIns="0" tIns="0" bIns="0" anchor="t">
+          <a:bodyPr wrap="square" lIns="0" tIns="0" rIns="0" bIns="0" anchor="t">
             <a:spAutoFit/>
           </a:bodyPr>
           <a:lstStyle/>
@@ -5829,7 +5877,7 @@
           <a:noFill/>
         </p:spPr>
         <p:txBody>
-          <a:bodyPr wrap="square" lIns="0" rIns="0" tIns="0" bIns="0" anchor="t">
+          <a:bodyPr wrap="square" lIns="0" tIns="0" rIns="0" bIns="0" anchor="t">
             <a:spAutoFit/>
           </a:bodyPr>
           <a:lstStyle/>
@@ -5864,7 +5912,7 @@
           <a:noFill/>
         </p:spPr>
         <p:txBody>
-          <a:bodyPr wrap="square" lIns="0" rIns="0" tIns="0" bIns="0" anchor="t">
+          <a:bodyPr wrap="square" lIns="0" tIns="0" rIns="0" bIns="0" anchor="t">
             <a:spAutoFit/>
           </a:bodyPr>
           <a:lstStyle/>
@@ -5919,7 +5967,7 @@
           </a:fontRef>
         </p:style>
         <p:txBody>
-          <a:bodyPr rtlCol="0" anchor="ctr" lIns="0" rIns="0" tIns="0" bIns="0"/>
+          <a:bodyPr lIns="0" tIns="0" rIns="0" bIns="0" rtlCol="0" anchor="ctr"/>
           <a:lstStyle/>
           <a:p>
             <a:pPr algn="ctr"/>
@@ -5972,7 +6020,7 @@
           </a:fontRef>
         </p:style>
         <p:txBody>
-          <a:bodyPr rtlCol="0" anchor="ctr" lIns="0" rIns="0" tIns="0" bIns="0"/>
+          <a:bodyPr lIns="0" tIns="0" rIns="0" bIns="0" rtlCol="0" anchor="ctr"/>
           <a:lstStyle/>
           <a:p>
             <a:pPr algn="ctr"/>
@@ -6005,7 +6053,7 @@
           <a:noFill/>
         </p:spPr>
         <p:txBody>
-          <a:bodyPr wrap="square" lIns="0" rIns="0" tIns="0" bIns="0" anchor="t">
+          <a:bodyPr wrap="square" lIns="0" tIns="0" rIns="0" bIns="0" anchor="t">
             <a:spAutoFit/>
           </a:bodyPr>
           <a:lstStyle/>
@@ -6040,7 +6088,7 @@
           <a:noFill/>
         </p:spPr>
         <p:txBody>
-          <a:bodyPr wrap="square" lIns="0" rIns="0" tIns="0" bIns="0" anchor="t">
+          <a:bodyPr wrap="square" lIns="0" tIns="0" rIns="0" bIns="0" anchor="t">
             <a:spAutoFit/>
           </a:bodyPr>
           <a:lstStyle/>
@@ -6143,6 +6191,7 @@
           <a:lstStyle/>
           <a:p>
             <a:pPr algn="ctr"/>
+            <a:endParaRPr/>
           </a:p>
         </p:txBody>
       </p:sp>
@@ -6163,7 +6212,7 @@
           <a:noFill/>
         </p:spPr>
         <p:txBody>
-          <a:bodyPr wrap="square" lIns="0" rIns="0" tIns="0" bIns="0" anchor="t">
+          <a:bodyPr wrap="square" lIns="0" tIns="0" rIns="0" bIns="0" anchor="t">
             <a:spAutoFit/>
           </a:bodyPr>
           <a:lstStyle/>
@@ -6213,7 +6262,7 @@
 </file>
 
 <file path=ppt/slides/slide14.xml><?xml version="1.0" encoding="utf-8"?>
-<p:sld xmlns:a="http://schemas.openxmlformats.org/drawingml/2006/main" xmlns:p="http://schemas.openxmlformats.org/presentationml/2006/main" xmlns:r="http://schemas.openxmlformats.org/officeDocument/2006/relationships">
+<p:sld xmlns:a="http://schemas.openxmlformats.org/drawingml/2006/main" xmlns:r="http://schemas.openxmlformats.org/officeDocument/2006/relationships" xmlns:p="http://schemas.openxmlformats.org/presentationml/2006/main">
   <p:cSld>
     <p:spTree>
       <p:nvGrpSpPr>
@@ -6221,7 +6270,14 @@
         <p:cNvGrpSpPr/>
         <p:nvPr/>
       </p:nvGrpSpPr>
-      <p:grpSpPr/>
+      <p:grpSpPr>
+        <a:xfrm>
+          <a:off x="0" y="0"/>
+          <a:ext cx="0" cy="0"/>
+          <a:chOff x="0" y="0"/>
+          <a:chExt cx="0" cy="0"/>
+        </a:xfrm>
+      </p:grpSpPr>
       <p:sp>
         <p:nvSpPr>
           <p:cNvPr id="2" name="Rectangle 1"/>
@@ -6263,6 +6319,7 @@
           <a:lstStyle/>
           <a:p>
             <a:pPr algn="ctr"/>
+            <a:endParaRPr/>
           </a:p>
         </p:txBody>
       </p:sp>
@@ -6283,7 +6340,7 @@
           <a:noFill/>
         </p:spPr>
         <p:txBody>
-          <a:bodyPr wrap="square" lIns="0" rIns="0" tIns="0" bIns="0" anchor="t">
+          <a:bodyPr wrap="square" lIns="0" tIns="0" rIns="0" bIns="0" anchor="t">
             <a:spAutoFit/>
           </a:bodyPr>
           <a:lstStyle/>
@@ -6318,7 +6375,7 @@
           <a:noFill/>
         </p:spPr>
         <p:txBody>
-          <a:bodyPr wrap="square" lIns="0" rIns="0" tIns="0" bIns="0" anchor="t">
+          <a:bodyPr wrap="square" lIns="0" tIns="0" rIns="0" bIns="0" anchor="t">
             <a:spAutoFit/>
           </a:bodyPr>
           <a:lstStyle/>
@@ -6353,7 +6410,7 @@
           <a:noFill/>
         </p:spPr>
         <p:txBody>
-          <a:bodyPr wrap="square" lIns="0" rIns="0" tIns="0" bIns="0" anchor="t">
+          <a:bodyPr wrap="square" lIns="0" tIns="0" rIns="0" bIns="0" anchor="t">
             <a:spAutoFit/>
           </a:bodyPr>
           <a:lstStyle/>
@@ -6388,7 +6445,7 @@
           <a:noFill/>
         </p:spPr>
         <p:txBody>
-          <a:bodyPr wrap="square" lIns="0" rIns="0" tIns="0" bIns="0" anchor="t">
+          <a:bodyPr wrap="square" lIns="0" tIns="0" rIns="0" bIns="0" anchor="t">
             <a:spAutoFit/>
           </a:bodyPr>
           <a:lstStyle/>
@@ -6423,7 +6480,7 @@
           <a:noFill/>
         </p:spPr>
         <p:txBody>
-          <a:bodyPr wrap="square" lIns="0" rIns="0" tIns="0" bIns="0" anchor="t">
+          <a:bodyPr wrap="square" lIns="0" tIns="0" rIns="0" bIns="0" anchor="t">
             <a:spAutoFit/>
           </a:bodyPr>
           <a:lstStyle/>
@@ -6458,7 +6515,7 @@
           <a:noFill/>
         </p:spPr>
         <p:txBody>
-          <a:bodyPr wrap="square" lIns="0" rIns="0" tIns="0" bIns="0" anchor="ctr">
+          <a:bodyPr wrap="square" lIns="0" tIns="0" rIns="0" bIns="0" anchor="ctr">
             <a:spAutoFit/>
           </a:bodyPr>
           <a:lstStyle/>
@@ -6517,6 +6574,7 @@
           <a:lstStyle/>
           <a:p>
             <a:pPr algn="ctr"/>
+            <a:endParaRPr/>
           </a:p>
         </p:txBody>
       </p:sp>
@@ -6528,8 +6586,8 @@
         </p:nvSpPr>
         <p:spPr>
           <a:xfrm>
-            <a:off x="640080" y="2011680"/>
-            <a:ext cx="1005840" cy="310896"/>
+            <a:off x="297543" y="2011680"/>
+            <a:ext cx="1348377" cy="310896"/>
           </a:xfrm>
           <a:prstGeom prst="roundRect">
             <a:avLst/>
@@ -6557,12 +6615,12 @@
           </a:fontRef>
         </p:style>
         <p:txBody>
-          <a:bodyPr rtlCol="0" anchor="ctr" lIns="0" rIns="0" tIns="0" bIns="0"/>
+          <a:bodyPr lIns="0" tIns="0" rIns="0" bIns="0" rtlCol="0" anchor="ctr"/>
           <a:lstStyle/>
           <a:p>
             <a:pPr algn="ctr"/>
             <a:r>
-              <a:rPr sz="1100" b="1" i="0">
+              <a:rPr sz="1100" b="1" i="0" dirty="0">
                 <a:solidFill>
                   <a:srgbClr val="FFFFFF"/>
                 </a:solidFill>
@@ -6590,7 +6648,7 @@
           <a:noFill/>
         </p:spPr>
         <p:txBody>
-          <a:bodyPr wrap="square" lIns="0" rIns="0" tIns="0" bIns="0" anchor="t">
+          <a:bodyPr wrap="square" lIns="0" tIns="0" rIns="0" bIns="0" anchor="t">
             <a:spAutoFit/>
           </a:bodyPr>
           <a:lstStyle/>
@@ -6616,8 +6674,8 @@
         </p:nvSpPr>
         <p:spPr>
           <a:xfrm>
-            <a:off x="640080" y="3017520"/>
-            <a:ext cx="1005840" cy="310896"/>
+            <a:off x="297543" y="3017520"/>
+            <a:ext cx="1348377" cy="310896"/>
           </a:xfrm>
           <a:prstGeom prst="roundRect">
             <a:avLst/>
@@ -6645,7 +6703,7 @@
           </a:fontRef>
         </p:style>
         <p:txBody>
-          <a:bodyPr rtlCol="0" anchor="ctr" lIns="0" rIns="0" tIns="0" bIns="0"/>
+          <a:bodyPr lIns="0" tIns="0" rIns="0" bIns="0" rtlCol="0" anchor="ctr"/>
           <a:lstStyle/>
           <a:p>
             <a:pPr algn="ctr"/>
@@ -6678,7 +6736,7 @@
           <a:noFill/>
         </p:spPr>
         <p:txBody>
-          <a:bodyPr wrap="square" lIns="0" rIns="0" tIns="0" bIns="0" anchor="t">
+          <a:bodyPr wrap="square" lIns="0" tIns="0" rIns="0" bIns="0" anchor="t">
             <a:spAutoFit/>
           </a:bodyPr>
           <a:lstStyle/>
@@ -6704,8 +6762,8 @@
         </p:nvSpPr>
         <p:spPr>
           <a:xfrm>
-            <a:off x="640080" y="4023360"/>
-            <a:ext cx="1005840" cy="310896"/>
+            <a:off x="297543" y="4023360"/>
+            <a:ext cx="1348377" cy="310896"/>
           </a:xfrm>
           <a:prstGeom prst="roundRect">
             <a:avLst/>
@@ -6733,12 +6791,12 @@
           </a:fontRef>
         </p:style>
         <p:txBody>
-          <a:bodyPr rtlCol="0" anchor="ctr" lIns="0" rIns="0" tIns="0" bIns="0"/>
+          <a:bodyPr lIns="0" tIns="0" rIns="0" bIns="0" rtlCol="0" anchor="ctr"/>
           <a:lstStyle/>
           <a:p>
             <a:pPr algn="ctr"/>
             <a:r>
-              <a:rPr sz="1100" b="1" i="0">
+              <a:rPr sz="1100" b="1" i="0" dirty="0">
                 <a:solidFill>
                   <a:srgbClr val="FFFFFF"/>
                 </a:solidFill>
@@ -6766,7 +6824,7 @@
           <a:noFill/>
         </p:spPr>
         <p:txBody>
-          <a:bodyPr wrap="square" lIns="0" rIns="0" tIns="0" bIns="0" anchor="t">
+          <a:bodyPr wrap="square" lIns="0" tIns="0" rIns="0" bIns="0" anchor="t">
             <a:spAutoFit/>
           </a:bodyPr>
           <a:lstStyle/>
@@ -6792,8 +6850,8 @@
         </p:nvSpPr>
         <p:spPr>
           <a:xfrm>
-            <a:off x="640080" y="5029200"/>
-            <a:ext cx="1005840" cy="310896"/>
+            <a:off x="297543" y="5029200"/>
+            <a:ext cx="1348377" cy="310896"/>
           </a:xfrm>
           <a:prstGeom prst="roundRect">
             <a:avLst/>
@@ -6821,12 +6879,12 @@
           </a:fontRef>
         </p:style>
         <p:txBody>
-          <a:bodyPr rtlCol="0" anchor="ctr" lIns="0" rIns="0" tIns="0" bIns="0"/>
+          <a:bodyPr lIns="0" tIns="0" rIns="0" bIns="0" rtlCol="0" anchor="ctr"/>
           <a:lstStyle/>
           <a:p>
             <a:pPr algn="ctr"/>
             <a:r>
-              <a:rPr sz="1100" b="1" i="0">
+              <a:rPr sz="1100" b="1" i="0" dirty="0">
                 <a:solidFill>
                   <a:srgbClr val="FFFFFF"/>
                 </a:solidFill>
@@ -6854,7 +6912,7 @@
           <a:noFill/>
         </p:spPr>
         <p:txBody>
-          <a:bodyPr wrap="square" lIns="0" rIns="0" tIns="0" bIns="0" anchor="t">
+          <a:bodyPr wrap="square" lIns="0" tIns="0" rIns="0" bIns="0" anchor="t">
             <a:spAutoFit/>
           </a:bodyPr>
           <a:lstStyle/>
@@ -6881,7 +6939,7 @@
 </file>
 
 <file path=ppt/slides/slide15.xml><?xml version="1.0" encoding="utf-8"?>
-<p:sld xmlns:a="http://schemas.openxmlformats.org/drawingml/2006/main" xmlns:p="http://schemas.openxmlformats.org/presentationml/2006/main" xmlns:r="http://schemas.openxmlformats.org/officeDocument/2006/relationships">
+<p:sld xmlns:a="http://schemas.openxmlformats.org/drawingml/2006/main" xmlns:r="http://schemas.openxmlformats.org/officeDocument/2006/relationships" xmlns:p="http://schemas.openxmlformats.org/presentationml/2006/main">
   <p:cSld>
     <p:spTree>
       <p:nvGrpSpPr>
@@ -6889,7 +6947,14 @@
         <p:cNvGrpSpPr/>
         <p:nvPr/>
       </p:nvGrpSpPr>
-      <p:grpSpPr/>
+      <p:grpSpPr>
+        <a:xfrm>
+          <a:off x="0" y="0"/>
+          <a:ext cx="0" cy="0"/>
+          <a:chOff x="0" y="0"/>
+          <a:chExt cx="0" cy="0"/>
+        </a:xfrm>
+      </p:grpSpPr>
       <p:sp>
         <p:nvSpPr>
           <p:cNvPr id="2" name="Rectangle 1"/>
@@ -6931,6 +6996,7 @@
           <a:lstStyle/>
           <a:p>
             <a:pPr algn="ctr"/>
+            <a:endParaRPr/>
           </a:p>
         </p:txBody>
       </p:sp>
@@ -6951,7 +7017,7 @@
           <a:noFill/>
         </p:spPr>
         <p:txBody>
-          <a:bodyPr wrap="square" lIns="0" rIns="0" tIns="0" bIns="0" anchor="t">
+          <a:bodyPr wrap="square" lIns="0" tIns="0" rIns="0" bIns="0" anchor="t">
             <a:spAutoFit/>
           </a:bodyPr>
           <a:lstStyle/>
@@ -6986,7 +7052,7 @@
           <a:noFill/>
         </p:spPr>
         <p:txBody>
-          <a:bodyPr wrap="square" lIns="0" rIns="0" tIns="0" bIns="0" anchor="t">
+          <a:bodyPr wrap="square" lIns="0" tIns="0" rIns="0" bIns="0" anchor="t">
             <a:spAutoFit/>
           </a:bodyPr>
           <a:lstStyle/>
@@ -7021,7 +7087,7 @@
           <a:noFill/>
         </p:spPr>
         <p:txBody>
-          <a:bodyPr wrap="square" lIns="0" rIns="0" tIns="0" bIns="0" anchor="t">
+          <a:bodyPr wrap="square" lIns="0" tIns="0" rIns="0" bIns="0" anchor="t">
             <a:spAutoFit/>
           </a:bodyPr>
           <a:lstStyle/>
@@ -7056,7 +7122,7 @@
           <a:noFill/>
         </p:spPr>
         <p:txBody>
-          <a:bodyPr wrap="square" lIns="0" rIns="0" tIns="0" bIns="0" anchor="t">
+          <a:bodyPr wrap="square" lIns="0" tIns="0" rIns="0" bIns="0" anchor="t">
             <a:spAutoFit/>
           </a:bodyPr>
           <a:lstStyle/>
@@ -7091,7 +7157,7 @@
           <a:noFill/>
         </p:spPr>
         <p:txBody>
-          <a:bodyPr wrap="square" lIns="0" rIns="0" tIns="0" bIns="0" anchor="t">
+          <a:bodyPr wrap="square" lIns="0" tIns="0" rIns="0" bIns="0" anchor="t">
             <a:spAutoFit/>
           </a:bodyPr>
           <a:lstStyle/>
@@ -7126,20 +7192,74 @@
           <a:noFill/>
         </p:spPr>
         <p:txBody>
-          <a:bodyPr wrap="square" lIns="0" rIns="0" tIns="0" bIns="0" anchor="t">
+          <a:bodyPr wrap="square" lIns="0" tIns="0" rIns="0" bIns="0" anchor="t">
             <a:spAutoFit/>
           </a:bodyPr>
           <a:lstStyle/>
           <a:p>
             <a:pPr algn="ctr"/>
             <a:r>
-              <a:rPr sz="2000" b="0" i="0">
+              <a:rPr sz="2000" b="0" i="0" dirty="0">
                 <a:solidFill>
                   <a:srgbClr val="605E5C"/>
                 </a:solidFill>
                 <a:latin typeface="Segoe UI Semibold"/>
               </a:rPr>
-              <a:t>A pergunta que define o roadmap dos próximos 12 meses</a:t>
+              <a:t>A </a:t>
+            </a:r>
+            <a:r>
+              <a:rPr sz="2000" b="0" i="0" dirty="0" err="1">
+                <a:solidFill>
+                  <a:srgbClr val="605E5C"/>
+                </a:solidFill>
+                <a:latin typeface="Segoe UI Semibold"/>
+              </a:rPr>
+              <a:t>pergunta</a:t>
+            </a:r>
+            <a:r>
+              <a:rPr sz="2000" b="0" i="0" dirty="0">
+                <a:solidFill>
+                  <a:srgbClr val="605E5C"/>
+                </a:solidFill>
+                <a:latin typeface="Segoe UI Semibold"/>
+              </a:rPr>
+              <a:t> </a:t>
+            </a:r>
+            <a:r>
+              <a:rPr sz="2000" b="0" i="0" dirty="0" err="1">
+                <a:solidFill>
+                  <a:srgbClr val="605E5C"/>
+                </a:solidFill>
+                <a:latin typeface="Segoe UI Semibold"/>
+              </a:rPr>
+              <a:t>que</a:t>
+            </a:r>
+            <a:r>
+              <a:rPr sz="2000" b="0" i="0" dirty="0">
+                <a:solidFill>
+                  <a:srgbClr val="605E5C"/>
+                </a:solidFill>
+                <a:latin typeface="Segoe UI Semibold"/>
+              </a:rPr>
+              <a:t> define o roadmap dos </a:t>
+            </a:r>
+            <a:r>
+              <a:rPr sz="2000" b="0" i="0" dirty="0" err="1">
+                <a:solidFill>
+                  <a:srgbClr val="605E5C"/>
+                </a:solidFill>
+                <a:latin typeface="Segoe UI Semibold"/>
+              </a:rPr>
+              <a:t>próximos</a:t>
+            </a:r>
+            <a:r>
+              <a:rPr sz="2000" b="0" i="0" dirty="0">
+                <a:solidFill>
+                  <a:srgbClr val="605E5C"/>
+                </a:solidFill>
+                <a:latin typeface="Segoe UI Semibold"/>
+              </a:rPr>
+              <a:t> 12 meses</a:t>
             </a:r>
           </a:p>
         </p:txBody>
@@ -7153,7 +7273,7 @@
         <p:spPr>
           <a:xfrm>
             <a:off x="640080" y="2194560"/>
-            <a:ext cx="10911535" cy="3108960"/>
+            <a:ext cx="10911535" cy="2740109"/>
           </a:xfrm>
           <a:prstGeom prst="rect">
             <a:avLst/>
@@ -7161,7 +7281,7 @@
           <a:noFill/>
         </p:spPr>
         <p:txBody>
-          <a:bodyPr wrap="square" lIns="0" rIns="0" tIns="0" bIns="0" anchor="t">
+          <a:bodyPr wrap="square" lIns="0" tIns="0" rIns="0" bIns="0" anchor="t">
             <a:spAutoFit/>
           </a:bodyPr>
           <a:lstStyle/>
@@ -7172,13 +7292,49 @@
               </a:lnSpc>
             </a:pPr>
             <a:r>
-              <a:rPr sz="4000" b="0" i="0">
+              <a:rPr sz="2800" b="0" i="0" dirty="0">
                 <a:solidFill>
                   <a:srgbClr val="002050"/>
                 </a:solidFill>
                 <a:latin typeface="Segoe UI"/>
               </a:rPr>
-              <a:t>A empresa precisa de</a:t>
+              <a:t>A </a:t>
+            </a:r>
+            <a:r>
+              <a:rPr sz="2800" b="0" i="0" dirty="0" err="1">
+                <a:solidFill>
+                  <a:srgbClr val="002050"/>
+                </a:solidFill>
+                <a:latin typeface="Segoe UI"/>
+              </a:rPr>
+              <a:t>empresa</a:t>
+            </a:r>
+            <a:r>
+              <a:rPr sz="2800" b="0" i="0" dirty="0">
+                <a:solidFill>
+                  <a:srgbClr val="002050"/>
+                </a:solidFill>
+                <a:latin typeface="Segoe UI"/>
+              </a:rPr>
+              <a:t> </a:t>
+            </a:r>
+            <a:r>
+              <a:rPr sz="2800" b="0" i="0" dirty="0" err="1">
+                <a:solidFill>
+                  <a:srgbClr val="002050"/>
+                </a:solidFill>
+                <a:latin typeface="Segoe UI"/>
+              </a:rPr>
+              <a:t>precisa</a:t>
+            </a:r>
+            <a:r>
+              <a:rPr sz="2800" b="0" i="0" dirty="0">
+                <a:solidFill>
+                  <a:srgbClr val="002050"/>
+                </a:solidFill>
+                <a:latin typeface="Segoe UI"/>
+              </a:rPr>
+              <a:t> de</a:t>
             </a:r>
           </a:p>
           <a:p>
@@ -7191,14 +7347,38 @@
               </a:spcBef>
             </a:pPr>
             <a:r>
-              <a:rPr sz="6400" b="1" i="0">
+              <a:rPr sz="4800" b="1" i="0" dirty="0" err="1">
                 <a:solidFill>
                   <a:srgbClr val="201F1E"/>
                 </a:solidFill>
                 <a:latin typeface="Segoe UI"/>
               </a:rPr>
-              <a:t>mais agentes</a:t>
-            </a:r>
+              <a:t>mais</a:t>
+            </a:r>
+            <a:r>
+              <a:rPr sz="4800" b="1" i="0" dirty="0">
+                <a:solidFill>
+                  <a:srgbClr val="201F1E"/>
+                </a:solidFill>
+                <a:latin typeface="Segoe UI"/>
+              </a:rPr>
+              <a:t> </a:t>
+            </a:r>
+            <a:r>
+              <a:rPr sz="4800" b="1" i="0" dirty="0" err="1">
+                <a:solidFill>
+                  <a:srgbClr val="201F1E"/>
+                </a:solidFill>
+                <a:latin typeface="Segoe UI"/>
+              </a:rPr>
+              <a:t>agentes</a:t>
+            </a:r>
+            <a:endParaRPr sz="4800" b="1" i="0" dirty="0">
+              <a:solidFill>
+                <a:srgbClr val="201F1E"/>
+              </a:solidFill>
+              <a:latin typeface="Segoe UI"/>
+            </a:endParaRPr>
           </a:p>
           <a:p>
             <a:pPr algn="ctr">
@@ -7210,13 +7390,22 @@
               </a:spcBef>
             </a:pPr>
             <a:r>
-              <a:rPr sz="4000" b="0" i="0">
+              <a:rPr sz="2800" b="0" i="0" dirty="0" err="1">
                 <a:solidFill>
                   <a:srgbClr val="002050"/>
                 </a:solidFill>
                 <a:latin typeface="Segoe UI"/>
               </a:rPr>
-              <a:t>ou de</a:t>
+              <a:t>ou</a:t>
+            </a:r>
+            <a:r>
+              <a:rPr sz="2800" b="0" i="0" dirty="0">
+                <a:solidFill>
+                  <a:srgbClr val="002050"/>
+                </a:solidFill>
+                <a:latin typeface="Segoe UI"/>
+              </a:rPr>
+              <a:t> de</a:t>
             </a:r>
           </a:p>
           <a:p>
@@ -7229,13 +7418,58 @@
               </a:spcBef>
             </a:pPr>
             <a:r>
-              <a:rPr sz="6400" b="1" i="0">
+              <a:rPr sz="4800" b="1" i="0" dirty="0" err="1">
                 <a:solidFill>
                   <a:srgbClr val="0078D4"/>
                 </a:solidFill>
                 <a:latin typeface="Segoe UI"/>
               </a:rPr>
-              <a:t>melhores capacidades reutilizáveis?</a:t>
+              <a:t>melhores</a:t>
+            </a:r>
+            <a:r>
+              <a:rPr sz="4800" b="1" i="0" dirty="0">
+                <a:solidFill>
+                  <a:srgbClr val="0078D4"/>
+                </a:solidFill>
+                <a:latin typeface="Segoe UI"/>
+              </a:rPr>
+              <a:t> </a:t>
+            </a:r>
+            <a:r>
+              <a:rPr sz="4800" b="1" i="0" dirty="0" err="1">
+                <a:solidFill>
+                  <a:srgbClr val="0078D4"/>
+                </a:solidFill>
+                <a:latin typeface="Segoe UI"/>
+              </a:rPr>
+              <a:t>capacidades</a:t>
+            </a:r>
+            <a:r>
+              <a:rPr sz="4800" b="1" i="0" dirty="0">
+                <a:solidFill>
+                  <a:srgbClr val="0078D4"/>
+                </a:solidFill>
+                <a:latin typeface="Segoe UI"/>
+              </a:rPr>
+              <a:t> </a:t>
+            </a:r>
+            <a:r>
+              <a:rPr sz="4800" b="1" i="0" dirty="0" err="1">
+                <a:solidFill>
+                  <a:srgbClr val="0078D4"/>
+                </a:solidFill>
+                <a:latin typeface="Segoe UI"/>
+              </a:rPr>
+              <a:t>reutilizáveis</a:t>
+            </a:r>
+            <a:r>
+              <a:rPr sz="4800" b="1" i="0" dirty="0">
+                <a:solidFill>
+                  <a:srgbClr val="0078D4"/>
+                </a:solidFill>
+                <a:latin typeface="Segoe UI"/>
+              </a:rPr>
+              <a:t>?</a:t>
             </a:r>
           </a:p>
         </p:txBody>
@@ -7257,7 +7491,7 @@
           <a:noFill/>
         </p:spPr>
         <p:txBody>
-          <a:bodyPr wrap="square" lIns="0" rIns="0" tIns="0" bIns="0" anchor="t">
+          <a:bodyPr wrap="square" lIns="0" tIns="0" rIns="0" bIns="0" anchor="t">
             <a:spAutoFit/>
           </a:bodyPr>
           <a:lstStyle/>
@@ -7284,7 +7518,7 @@
 </file>
 
 <file path=ppt/slides/slide16.xml><?xml version="1.0" encoding="utf-8"?>
-<p:sld xmlns:a="http://schemas.openxmlformats.org/drawingml/2006/main" xmlns:p="http://schemas.openxmlformats.org/presentationml/2006/main" xmlns:r="http://schemas.openxmlformats.org/officeDocument/2006/relationships">
+<p:sld xmlns:a="http://schemas.openxmlformats.org/drawingml/2006/main" xmlns:r="http://schemas.openxmlformats.org/officeDocument/2006/relationships" xmlns:p="http://schemas.openxmlformats.org/presentationml/2006/main">
   <p:cSld>
     <p:spTree>
       <p:nvGrpSpPr>
@@ -7292,7 +7526,14 @@
         <p:cNvGrpSpPr/>
         <p:nvPr/>
       </p:nvGrpSpPr>
-      <p:grpSpPr/>
+      <p:grpSpPr>
+        <a:xfrm>
+          <a:off x="0" y="0"/>
+          <a:ext cx="0" cy="0"/>
+          <a:chOff x="0" y="0"/>
+          <a:chExt cx="0" cy="0"/>
+        </a:xfrm>
+      </p:grpSpPr>
       <p:sp>
         <p:nvSpPr>
           <p:cNvPr id="2" name="Rectangle 1"/>
@@ -7334,6 +7575,7 @@
           <a:lstStyle/>
           <a:p>
             <a:pPr algn="ctr"/>
+            <a:endParaRPr/>
           </a:p>
         </p:txBody>
       </p:sp>
@@ -7354,7 +7596,7 @@
           <a:noFill/>
         </p:spPr>
         <p:txBody>
-          <a:bodyPr wrap="square" lIns="0" rIns="0" tIns="0" bIns="0" anchor="t">
+          <a:bodyPr wrap="square" lIns="0" tIns="0" rIns="0" bIns="0" anchor="t">
             <a:spAutoFit/>
           </a:bodyPr>
           <a:lstStyle/>
@@ -7389,7 +7631,7 @@
           <a:noFill/>
         </p:spPr>
         <p:txBody>
-          <a:bodyPr wrap="square" lIns="0" rIns="0" tIns="0" bIns="0" anchor="t">
+          <a:bodyPr wrap="square" lIns="0" tIns="0" rIns="0" bIns="0" anchor="t">
             <a:spAutoFit/>
           </a:bodyPr>
           <a:lstStyle/>
@@ -7424,7 +7666,7 @@
           <a:noFill/>
         </p:spPr>
         <p:txBody>
-          <a:bodyPr wrap="square" lIns="0" rIns="0" tIns="0" bIns="0" anchor="t">
+          <a:bodyPr wrap="square" lIns="0" tIns="0" rIns="0" bIns="0" anchor="t">
             <a:spAutoFit/>
           </a:bodyPr>
           <a:lstStyle/>
@@ -7459,7 +7701,7 @@
           <a:noFill/>
         </p:spPr>
         <p:txBody>
-          <a:bodyPr wrap="square" lIns="0" rIns="0" tIns="0" bIns="0" anchor="t">
+          <a:bodyPr wrap="square" lIns="0" tIns="0" rIns="0" bIns="0" anchor="t">
             <a:spAutoFit/>
           </a:bodyPr>
           <a:lstStyle/>
@@ -7494,7 +7736,7 @@
           <a:noFill/>
         </p:spPr>
         <p:txBody>
-          <a:bodyPr wrap="square" lIns="0" rIns="0" tIns="0" bIns="0" anchor="t">
+          <a:bodyPr wrap="square" lIns="0" tIns="0" rIns="0" bIns="0" anchor="t">
             <a:spAutoFit/>
           </a:bodyPr>
           <a:lstStyle/>
@@ -7529,7 +7771,7 @@
           <a:noFill/>
         </p:spPr>
         <p:txBody>
-          <a:bodyPr wrap="square" lIns="0" rIns="0" tIns="0" bIns="0" anchor="ctr">
+          <a:bodyPr wrap="square" lIns="0" tIns="0" rIns="0" bIns="0" anchor="ctr">
             <a:spAutoFit/>
           </a:bodyPr>
           <a:lstStyle/>
@@ -7588,6 +7830,7 @@
           <a:lstStyle/>
           <a:p>
             <a:pPr algn="ctr"/>
+            <a:endParaRPr/>
           </a:p>
         </p:txBody>
       </p:sp>
@@ -7608,7 +7851,7 @@
           <a:noFill/>
         </p:spPr>
         <p:txBody>
-          <a:bodyPr wrap="square" lIns="0" rIns="0" tIns="0" bIns="0" anchor="t">
+          <a:bodyPr wrap="square" lIns="0" tIns="0" rIns="0" bIns="0" anchor="t">
             <a:spAutoFit/>
           </a:bodyPr>
           <a:lstStyle/>
@@ -7766,6 +8009,7 @@
           <a:lstStyle/>
           <a:p>
             <a:pPr algn="ctr"/>
+            <a:endParaRPr/>
           </a:p>
         </p:txBody>
       </p:sp>
@@ -7810,6 +8054,7 @@
           <a:lstStyle/>
           <a:p>
             <a:pPr algn="ctr"/>
+            <a:endParaRPr/>
           </a:p>
         </p:txBody>
       </p:sp>
@@ -7830,7 +8075,7 @@
           <a:noFill/>
         </p:spPr>
         <p:txBody>
-          <a:bodyPr wrap="square" lIns="0" rIns="0" tIns="0" bIns="0" anchor="t">
+          <a:bodyPr wrap="square" lIns="0" tIns="0" rIns="0" bIns="0" anchor="t">
             <a:spAutoFit/>
           </a:bodyPr>
           <a:lstStyle/>
@@ -7857,7 +8102,7 @@
 </file>
 
 <file path=ppt/slides/slide17.xml><?xml version="1.0" encoding="utf-8"?>
-<p:sld xmlns:a="http://schemas.openxmlformats.org/drawingml/2006/main" xmlns:p="http://schemas.openxmlformats.org/presentationml/2006/main" xmlns:r="http://schemas.openxmlformats.org/officeDocument/2006/relationships">
+<p:sld xmlns:a="http://schemas.openxmlformats.org/drawingml/2006/main" xmlns:r="http://schemas.openxmlformats.org/officeDocument/2006/relationships" xmlns:p="http://schemas.openxmlformats.org/presentationml/2006/main">
   <p:cSld>
     <p:spTree>
       <p:nvGrpSpPr>
@@ -7865,7 +8110,14 @@
         <p:cNvGrpSpPr/>
         <p:nvPr/>
       </p:nvGrpSpPr>
-      <p:grpSpPr/>
+      <p:grpSpPr>
+        <a:xfrm>
+          <a:off x="0" y="0"/>
+          <a:ext cx="0" cy="0"/>
+          <a:chOff x="0" y="0"/>
+          <a:chExt cx="0" cy="0"/>
+        </a:xfrm>
+      </p:grpSpPr>
       <p:sp>
         <p:nvSpPr>
           <p:cNvPr id="2" name="Rectangle 1"/>
@@ -7907,6 +8159,7 @@
           <a:lstStyle/>
           <a:p>
             <a:pPr algn="ctr"/>
+            <a:endParaRPr/>
           </a:p>
         </p:txBody>
       </p:sp>
@@ -7927,7 +8180,7 @@
           <a:noFill/>
         </p:spPr>
         <p:txBody>
-          <a:bodyPr wrap="square" lIns="0" rIns="0" tIns="0" bIns="0" anchor="t">
+          <a:bodyPr wrap="square" lIns="0" tIns="0" rIns="0" bIns="0" anchor="t">
             <a:spAutoFit/>
           </a:bodyPr>
           <a:lstStyle/>
@@ -7962,7 +8215,7 @@
           <a:noFill/>
         </p:spPr>
         <p:txBody>
-          <a:bodyPr wrap="square" lIns="0" rIns="0" tIns="0" bIns="0" anchor="t">
+          <a:bodyPr wrap="square" lIns="0" tIns="0" rIns="0" bIns="0" anchor="t">
             <a:spAutoFit/>
           </a:bodyPr>
           <a:lstStyle/>
@@ -7997,7 +8250,7 @@
           <a:noFill/>
         </p:spPr>
         <p:txBody>
-          <a:bodyPr wrap="square" lIns="0" rIns="0" tIns="0" bIns="0" anchor="t">
+          <a:bodyPr wrap="square" lIns="0" tIns="0" rIns="0" bIns="0" anchor="t">
             <a:spAutoFit/>
           </a:bodyPr>
           <a:lstStyle/>
@@ -8032,7 +8285,7 @@
           <a:noFill/>
         </p:spPr>
         <p:txBody>
-          <a:bodyPr wrap="square" lIns="0" rIns="0" tIns="0" bIns="0" anchor="t">
+          <a:bodyPr wrap="square" lIns="0" tIns="0" rIns="0" bIns="0" anchor="t">
             <a:spAutoFit/>
           </a:bodyPr>
           <a:lstStyle/>
@@ -8067,7 +8320,7 @@
           <a:noFill/>
         </p:spPr>
         <p:txBody>
-          <a:bodyPr wrap="square" lIns="0" rIns="0" tIns="0" bIns="0" anchor="t">
+          <a:bodyPr wrap="square" lIns="0" tIns="0" rIns="0" bIns="0" anchor="t">
             <a:spAutoFit/>
           </a:bodyPr>
           <a:lstStyle/>
@@ -8094,7 +8347,7 @@
         <p:spPr>
           <a:xfrm>
             <a:off x="640080" y="2194560"/>
-            <a:ext cx="10911535" cy="2743200"/>
+            <a:ext cx="10911535" cy="2160528"/>
           </a:xfrm>
           <a:prstGeom prst="rect">
             <a:avLst/>
@@ -8102,7 +8355,7 @@
           <a:noFill/>
         </p:spPr>
         <p:txBody>
-          <a:bodyPr wrap="square" lIns="0" rIns="0" tIns="0" bIns="0" anchor="t">
+          <a:bodyPr wrap="square" lIns="0" tIns="0" rIns="0" bIns="0" anchor="t">
             <a:spAutoFit/>
           </a:bodyPr>
           <a:lstStyle/>
@@ -8113,13 +8366,31 @@
               </a:lnSpc>
             </a:pPr>
             <a:r>
-              <a:rPr sz="8400" b="1" i="0">
+              <a:rPr sz="6600" b="1" i="0" dirty="0">
                 <a:solidFill>
                   <a:srgbClr val="FFFFFF"/>
                 </a:solidFill>
                 <a:latin typeface="Segoe UI"/>
               </a:rPr>
-              <a:t>Menos agentes.</a:t>
+              <a:t>Menos </a:t>
+            </a:r>
+            <a:r>
+              <a:rPr sz="6600" b="1" i="0" dirty="0" err="1">
+                <a:solidFill>
+                  <a:srgbClr val="FFFFFF"/>
+                </a:solidFill>
+                <a:latin typeface="Segoe UI"/>
+              </a:rPr>
+              <a:t>agentes</a:t>
+            </a:r>
+            <a:r>
+              <a:rPr sz="6600" b="1" i="0" dirty="0">
+                <a:solidFill>
+                  <a:srgbClr val="FFFFFF"/>
+                </a:solidFill>
+                <a:latin typeface="Segoe UI"/>
+              </a:rPr>
+              <a:t>.</a:t>
             </a:r>
           </a:p>
           <a:p>
@@ -8132,13 +8403,31 @@
               </a:spcBef>
             </a:pPr>
             <a:r>
-              <a:rPr sz="8400" b="1" i="0">
+              <a:rPr sz="6600" b="1" i="0" dirty="0">
                 <a:solidFill>
                   <a:srgbClr val="50E6FF"/>
                 </a:solidFill>
                 <a:latin typeface="Segoe UI"/>
               </a:rPr>
-              <a:t>Mais capacidades.</a:t>
+              <a:t>Mais </a:t>
+            </a:r>
+            <a:r>
+              <a:rPr sz="6600" b="1" i="0" dirty="0" err="1">
+                <a:solidFill>
+                  <a:srgbClr val="50E6FF"/>
+                </a:solidFill>
+                <a:latin typeface="Segoe UI"/>
+              </a:rPr>
+              <a:t>capacidades</a:t>
+            </a:r>
+            <a:r>
+              <a:rPr sz="6600" b="1" i="0" dirty="0">
+                <a:solidFill>
+                  <a:srgbClr val="50E6FF"/>
+                </a:solidFill>
+                <a:latin typeface="Segoe UI"/>
+              </a:rPr>
+              <a:t>.</a:t>
             </a:r>
           </a:p>
         </p:txBody>
@@ -8184,6 +8473,7 @@
           <a:lstStyle/>
           <a:p>
             <a:pPr algn="ctr"/>
+            <a:endParaRPr/>
           </a:p>
         </p:txBody>
       </p:sp>
@@ -8204,7 +8494,7 @@
           <a:noFill/>
         </p:spPr>
         <p:txBody>
-          <a:bodyPr wrap="square" lIns="0" rIns="0" tIns="0" bIns="0" anchor="t">
+          <a:bodyPr wrap="square" lIns="0" tIns="0" rIns="0" bIns="0" anchor="t">
             <a:spAutoFit/>
           </a:bodyPr>
           <a:lstStyle/>
@@ -8273,7 +8563,7 @@
 </file>
 
 <file path=ppt/slides/slide2.xml><?xml version="1.0" encoding="utf-8"?>
-<p:sld xmlns:a="http://schemas.openxmlformats.org/drawingml/2006/main" xmlns:p="http://schemas.openxmlformats.org/presentationml/2006/main" xmlns:r="http://schemas.openxmlformats.org/officeDocument/2006/relationships">
+<p:sld xmlns:a="http://schemas.openxmlformats.org/drawingml/2006/main" xmlns:r="http://schemas.openxmlformats.org/officeDocument/2006/relationships" xmlns:p="http://schemas.openxmlformats.org/presentationml/2006/main">
   <p:cSld>
     <p:spTree>
       <p:nvGrpSpPr>
@@ -8281,7 +8571,14 @@
         <p:cNvGrpSpPr/>
         <p:nvPr/>
       </p:nvGrpSpPr>
-      <p:grpSpPr/>
+      <p:grpSpPr>
+        <a:xfrm>
+          <a:off x="0" y="0"/>
+          <a:ext cx="0" cy="0"/>
+          <a:chOff x="0" y="0"/>
+          <a:chExt cx="0" cy="0"/>
+        </a:xfrm>
+      </p:grpSpPr>
       <p:sp>
         <p:nvSpPr>
           <p:cNvPr id="2" name="Rectangle 1"/>
@@ -8323,6 +8620,7 @@
           <a:lstStyle/>
           <a:p>
             <a:pPr algn="ctr"/>
+            <a:endParaRPr/>
           </a:p>
         </p:txBody>
       </p:sp>
@@ -8343,7 +8641,7 @@
           <a:noFill/>
         </p:spPr>
         <p:txBody>
-          <a:bodyPr wrap="square" lIns="0" rIns="0" tIns="0" bIns="0" anchor="t">
+          <a:bodyPr wrap="square" lIns="0" tIns="0" rIns="0" bIns="0" anchor="t">
             <a:spAutoFit/>
           </a:bodyPr>
           <a:lstStyle/>
@@ -8378,7 +8676,7 @@
           <a:noFill/>
         </p:spPr>
         <p:txBody>
-          <a:bodyPr wrap="square" lIns="0" rIns="0" tIns="0" bIns="0" anchor="t">
+          <a:bodyPr wrap="square" lIns="0" tIns="0" rIns="0" bIns="0" anchor="t">
             <a:spAutoFit/>
           </a:bodyPr>
           <a:lstStyle/>
@@ -8413,7 +8711,7 @@
           <a:noFill/>
         </p:spPr>
         <p:txBody>
-          <a:bodyPr wrap="square" lIns="0" rIns="0" tIns="0" bIns="0" anchor="t">
+          <a:bodyPr wrap="square" lIns="0" tIns="0" rIns="0" bIns="0" anchor="t">
             <a:spAutoFit/>
           </a:bodyPr>
           <a:lstStyle/>
@@ -8448,7 +8746,7 @@
           <a:noFill/>
         </p:spPr>
         <p:txBody>
-          <a:bodyPr wrap="square" lIns="0" rIns="0" tIns="0" bIns="0" anchor="t">
+          <a:bodyPr wrap="square" lIns="0" tIns="0" rIns="0" bIns="0" anchor="t">
             <a:spAutoFit/>
           </a:bodyPr>
           <a:lstStyle/>
@@ -8483,7 +8781,7 @@
           <a:noFill/>
         </p:spPr>
         <p:txBody>
-          <a:bodyPr wrap="square" lIns="0" rIns="0" tIns="0" bIns="0" anchor="t">
+          <a:bodyPr wrap="square" lIns="0" tIns="0" rIns="0" bIns="0" anchor="t">
             <a:spAutoFit/>
           </a:bodyPr>
           <a:lstStyle/>
@@ -8518,7 +8816,7 @@
           <a:noFill/>
         </p:spPr>
         <p:txBody>
-          <a:bodyPr wrap="square" lIns="0" rIns="0" tIns="0" bIns="0" anchor="ctr">
+          <a:bodyPr wrap="square" lIns="0" tIns="0" rIns="0" bIns="0" anchor="ctr">
             <a:spAutoFit/>
           </a:bodyPr>
           <a:lstStyle/>
@@ -8577,6 +8875,7 @@
           <a:lstStyle/>
           <a:p>
             <a:pPr algn="ctr"/>
+            <a:endParaRPr/>
           </a:p>
         </p:txBody>
       </p:sp>
@@ -8597,7 +8896,7 @@
           <a:noFill/>
         </p:spPr>
         <p:txBody>
-          <a:bodyPr wrap="square" lIns="0" rIns="0" tIns="0" bIns="0" anchor="t">
+          <a:bodyPr wrap="square" lIns="0" tIns="0" rIns="0" bIns="0" anchor="t">
             <a:spAutoFit/>
           </a:bodyPr>
           <a:lstStyle/>
@@ -8707,7 +9006,7 @@
 </file>
 
 <file path=ppt/slides/slide3.xml><?xml version="1.0" encoding="utf-8"?>
-<p:sld xmlns:a="http://schemas.openxmlformats.org/drawingml/2006/main" xmlns:p="http://schemas.openxmlformats.org/presentationml/2006/main" xmlns:r="http://schemas.openxmlformats.org/officeDocument/2006/relationships">
+<p:sld xmlns:a="http://schemas.openxmlformats.org/drawingml/2006/main" xmlns:r="http://schemas.openxmlformats.org/officeDocument/2006/relationships" xmlns:p="http://schemas.openxmlformats.org/presentationml/2006/main">
   <p:cSld>
     <p:spTree>
       <p:nvGrpSpPr>
@@ -8715,7 +9014,14 @@
         <p:cNvGrpSpPr/>
         <p:nvPr/>
       </p:nvGrpSpPr>
-      <p:grpSpPr/>
+      <p:grpSpPr>
+        <a:xfrm>
+          <a:off x="0" y="0"/>
+          <a:ext cx="0" cy="0"/>
+          <a:chOff x="0" y="0"/>
+          <a:chExt cx="0" cy="0"/>
+        </a:xfrm>
+      </p:grpSpPr>
       <p:sp>
         <p:nvSpPr>
           <p:cNvPr id="2" name="Rectangle 1"/>
@@ -8757,6 +9063,7 @@
           <a:lstStyle/>
           <a:p>
             <a:pPr algn="ctr"/>
+            <a:endParaRPr/>
           </a:p>
         </p:txBody>
       </p:sp>
@@ -8777,7 +9084,7 @@
           <a:noFill/>
         </p:spPr>
         <p:txBody>
-          <a:bodyPr wrap="square" lIns="0" rIns="0" tIns="0" bIns="0" anchor="t">
+          <a:bodyPr wrap="square" lIns="0" tIns="0" rIns="0" bIns="0" anchor="t">
             <a:spAutoFit/>
           </a:bodyPr>
           <a:lstStyle/>
@@ -8812,7 +9119,7 @@
           <a:noFill/>
         </p:spPr>
         <p:txBody>
-          <a:bodyPr wrap="square" lIns="0" rIns="0" tIns="0" bIns="0" anchor="t">
+          <a:bodyPr wrap="square" lIns="0" tIns="0" rIns="0" bIns="0" anchor="t">
             <a:spAutoFit/>
           </a:bodyPr>
           <a:lstStyle/>
@@ -8847,7 +9154,7 @@
           <a:noFill/>
         </p:spPr>
         <p:txBody>
-          <a:bodyPr wrap="square" lIns="0" rIns="0" tIns="0" bIns="0" anchor="t">
+          <a:bodyPr wrap="square" lIns="0" tIns="0" rIns="0" bIns="0" anchor="t">
             <a:spAutoFit/>
           </a:bodyPr>
           <a:lstStyle/>
@@ -8882,7 +9189,7 @@
           <a:noFill/>
         </p:spPr>
         <p:txBody>
-          <a:bodyPr wrap="square" lIns="0" rIns="0" tIns="0" bIns="0" anchor="t">
+          <a:bodyPr wrap="square" lIns="0" tIns="0" rIns="0" bIns="0" anchor="t">
             <a:spAutoFit/>
           </a:bodyPr>
           <a:lstStyle/>
@@ -8917,7 +9224,7 @@
           <a:noFill/>
         </p:spPr>
         <p:txBody>
-          <a:bodyPr wrap="square" lIns="0" rIns="0" tIns="0" bIns="0" anchor="t">
+          <a:bodyPr wrap="square" lIns="0" tIns="0" rIns="0" bIns="0" anchor="t">
             <a:spAutoFit/>
           </a:bodyPr>
           <a:lstStyle/>
@@ -8952,7 +9259,7 @@
           <a:noFill/>
         </p:spPr>
         <p:txBody>
-          <a:bodyPr wrap="square" lIns="0" rIns="0" tIns="0" bIns="0" anchor="ctr">
+          <a:bodyPr wrap="square" lIns="0" tIns="0" rIns="0" bIns="0" anchor="ctr">
             <a:spAutoFit/>
           </a:bodyPr>
           <a:lstStyle/>
@@ -9011,6 +9318,7 @@
           <a:lstStyle/>
           <a:p>
             <a:pPr algn="ctr"/>
+            <a:endParaRPr/>
           </a:p>
         </p:txBody>
       </p:sp>
@@ -9023,7 +9331,7 @@
         <p:spPr>
           <a:xfrm>
             <a:off x="640080" y="1965960"/>
-            <a:ext cx="1196721" cy="310896"/>
+            <a:ext cx="3641634" cy="310896"/>
           </a:xfrm>
           <a:prstGeom prst="roundRect">
             <a:avLst/>
@@ -9051,19 +9359,115 @@
           </a:fontRef>
         </p:style>
         <p:txBody>
-          <a:bodyPr rtlCol="0" anchor="ctr" lIns="0" rIns="0" tIns="0" bIns="0"/>
+          <a:bodyPr lIns="0" tIns="0" rIns="0" bIns="0" rtlCol="0" anchor="ctr"/>
           <a:lstStyle/>
           <a:p>
             <a:pPr algn="ctr"/>
             <a:r>
-              <a:rPr sz="1100" b="1" i="0">
+              <a:rPr sz="1100" b="1" i="0" dirty="0" err="1">
                 <a:solidFill>
                   <a:srgbClr val="FFFFFF"/>
                 </a:solidFill>
                 <a:latin typeface="Segoe UI Semibold"/>
               </a:rPr>
-              <a:t>Padrão observado em quase toda enterprise hoje</a:t>
-            </a:r>
+              <a:t>Padrão</a:t>
+            </a:r>
+            <a:r>
+              <a:rPr sz="1100" b="1" i="0" dirty="0">
+                <a:solidFill>
+                  <a:srgbClr val="FFFFFF"/>
+                </a:solidFill>
+                <a:latin typeface="Segoe UI Semibold"/>
+              </a:rPr>
+              <a:t> </a:t>
+            </a:r>
+            <a:r>
+              <a:rPr sz="1100" b="1" i="0" dirty="0" err="1">
+                <a:solidFill>
+                  <a:srgbClr val="FFFFFF"/>
+                </a:solidFill>
+                <a:latin typeface="Segoe UI Semibold"/>
+              </a:rPr>
+              <a:t>observado</a:t>
+            </a:r>
+            <a:r>
+              <a:rPr sz="1100" b="1" i="0" dirty="0">
+                <a:solidFill>
+                  <a:srgbClr val="FFFFFF"/>
+                </a:solidFill>
+                <a:latin typeface="Segoe UI Semibold"/>
+              </a:rPr>
+              <a:t> </a:t>
+            </a:r>
+            <a:r>
+              <a:rPr sz="1100" b="1" i="0" dirty="0" err="1">
+                <a:solidFill>
+                  <a:srgbClr val="FFFFFF"/>
+                </a:solidFill>
+                <a:latin typeface="Segoe UI Semibold"/>
+              </a:rPr>
+              <a:t>em</a:t>
+            </a:r>
+            <a:r>
+              <a:rPr sz="1100" b="1" i="0" dirty="0">
+                <a:solidFill>
+                  <a:srgbClr val="FFFFFF"/>
+                </a:solidFill>
+                <a:latin typeface="Segoe UI Semibold"/>
+              </a:rPr>
+              <a:t> </a:t>
+            </a:r>
+            <a:r>
+              <a:rPr sz="1100" b="1" i="0" dirty="0" err="1">
+                <a:solidFill>
+                  <a:srgbClr val="FFFFFF"/>
+                </a:solidFill>
+                <a:latin typeface="Segoe UI Semibold"/>
+              </a:rPr>
+              <a:t>quase</a:t>
+            </a:r>
+            <a:r>
+              <a:rPr sz="1100" b="1" i="0" dirty="0">
+                <a:solidFill>
+                  <a:srgbClr val="FFFFFF"/>
+                </a:solidFill>
+                <a:latin typeface="Segoe UI Semibold"/>
+              </a:rPr>
+              <a:t> </a:t>
+            </a:r>
+            <a:r>
+              <a:rPr sz="1100" b="1" i="0" dirty="0" err="1">
+                <a:solidFill>
+                  <a:srgbClr val="FFFFFF"/>
+                </a:solidFill>
+                <a:latin typeface="Segoe UI Semibold"/>
+              </a:rPr>
+              <a:t>toda</a:t>
+            </a:r>
+            <a:r>
+              <a:rPr sz="1100" b="1" i="0" dirty="0">
+                <a:solidFill>
+                  <a:srgbClr val="FFFFFF"/>
+                </a:solidFill>
+                <a:latin typeface="Segoe UI Semibold"/>
+              </a:rPr>
+              <a:t> enterprise </a:t>
+            </a:r>
+            <a:r>
+              <a:rPr sz="1100" b="1" i="0" dirty="0" err="1">
+                <a:solidFill>
+                  <a:srgbClr val="FFFFFF"/>
+                </a:solidFill>
+                <a:latin typeface="Segoe UI Semibold"/>
+              </a:rPr>
+              <a:t>hoje</a:t>
+            </a:r>
+            <a:endParaRPr sz="1100" b="1" i="0" dirty="0">
+              <a:solidFill>
+                <a:srgbClr val="FFFFFF"/>
+              </a:solidFill>
+              <a:latin typeface="Segoe UI Semibold"/>
+            </a:endParaRPr>
           </a:p>
         </p:txBody>
       </p:sp>
@@ -9086,9 +9490,27 @@
                 <a:tableStyleId>{5C22544A-7EE6-4342-B048-85BDC9FD1C3A}</a:tableStyleId>
               </a:tblPr>
               <a:tblGrid>
-                <a:gridCol w="3637178"/>
-                <a:gridCol w="3637178"/>
-                <a:gridCol w="3637179"/>
+                <a:gridCol w="3637178">
+                  <a:extLst>
+                    <a:ext uri="{9D8B030D-6E8A-4147-A177-3AD203B41FA5}">
+                      <a16:colId xmlns:a16="http://schemas.microsoft.com/office/drawing/2014/main" val="20000"/>
+                    </a:ext>
+                  </a:extLst>
+                </a:gridCol>
+                <a:gridCol w="3637178">
+                  <a:extLst>
+                    <a:ext uri="{9D8B030D-6E8A-4147-A177-3AD203B41FA5}">
+                      <a16:colId xmlns:a16="http://schemas.microsoft.com/office/drawing/2014/main" val="20001"/>
+                    </a:ext>
+                  </a:extLst>
+                </a:gridCol>
+                <a:gridCol w="3637179">
+                  <a:extLst>
+                    <a:ext uri="{9D8B030D-6E8A-4147-A177-3AD203B41FA5}">
+                      <a16:colId xmlns:a16="http://schemas.microsoft.com/office/drawing/2014/main" val="20002"/>
+                    </a:ext>
+                  </a:extLst>
+                </a:gridCol>
               </a:tblGrid>
               <a:tr h="518160">
                 <a:tc>
@@ -9157,6 +9579,11 @@
                     </a:solidFill>
                   </a:tcPr>
                 </a:tc>
+                <a:extLst>
+                  <a:ext uri="{0D108BD9-81ED-4DB2-BD59-A6C34878D82A}">
+                    <a16:rowId xmlns:a16="http://schemas.microsoft.com/office/drawing/2014/main" val="10000"/>
+                  </a:ext>
+                </a:extLst>
               </a:tr>
               <a:tr h="518160">
                 <a:tc>
@@ -9175,7 +9602,7 @@
                       </a:r>
                     </a:p>
                   </a:txBody>
-                  <a:tcPr marL="109728" marR="109728" marT="45720" marB="45720">
+                  <a:tcPr marL="109728" marR="109728">
                     <a:solidFill>
                       <a:srgbClr val="FFFFFF"/>
                     </a:solidFill>
@@ -9197,7 +9624,7 @@
                       </a:r>
                     </a:p>
                   </a:txBody>
-                  <a:tcPr marL="109728" marR="109728" marT="45720" marB="45720">
+                  <a:tcPr marL="109728" marR="109728">
                     <a:solidFill>
                       <a:srgbClr val="FFFFFF"/>
                     </a:solidFill>
@@ -9219,12 +9646,17 @@
                       </a:r>
                     </a:p>
                   </a:txBody>
-                  <a:tcPr marL="109728" marR="109728" marT="45720" marB="45720">
+                  <a:tcPr marL="109728" marR="109728">
                     <a:solidFill>
                       <a:srgbClr val="FFFFFF"/>
                     </a:solidFill>
                   </a:tcPr>
                 </a:tc>
+                <a:extLst>
+                  <a:ext uri="{0D108BD9-81ED-4DB2-BD59-A6C34878D82A}">
+                    <a16:rowId xmlns:a16="http://schemas.microsoft.com/office/drawing/2014/main" val="10001"/>
+                  </a:ext>
+                </a:extLst>
               </a:tr>
               <a:tr h="518160">
                 <a:tc>
@@ -9243,7 +9675,7 @@
                       </a:r>
                     </a:p>
                   </a:txBody>
-                  <a:tcPr marL="109728" marR="109728" marT="45720" marB="45720">
+                  <a:tcPr marL="109728" marR="109728">
                     <a:solidFill>
                       <a:srgbClr val="FAFAFA"/>
                     </a:solidFill>
@@ -9265,7 +9697,7 @@
                       </a:r>
                     </a:p>
                   </a:txBody>
-                  <a:tcPr marL="109728" marR="109728" marT="45720" marB="45720">
+                  <a:tcPr marL="109728" marR="109728">
                     <a:solidFill>
                       <a:srgbClr val="FAFAFA"/>
                     </a:solidFill>
@@ -9287,12 +9719,17 @@
                       </a:r>
                     </a:p>
                   </a:txBody>
-                  <a:tcPr marL="109728" marR="109728" marT="45720" marB="45720">
+                  <a:tcPr marL="109728" marR="109728">
                     <a:solidFill>
                       <a:srgbClr val="FAFAFA"/>
                     </a:solidFill>
                   </a:tcPr>
                 </a:tc>
+                <a:extLst>
+                  <a:ext uri="{0D108BD9-81ED-4DB2-BD59-A6C34878D82A}">
+                    <a16:rowId xmlns:a16="http://schemas.microsoft.com/office/drawing/2014/main" val="10002"/>
+                  </a:ext>
+                </a:extLst>
               </a:tr>
               <a:tr h="518160">
                 <a:tc>
@@ -9311,7 +9748,7 @@
                       </a:r>
                     </a:p>
                   </a:txBody>
-                  <a:tcPr marL="109728" marR="109728" marT="45720" marB="45720">
+                  <a:tcPr marL="109728" marR="109728">
                     <a:solidFill>
                       <a:srgbClr val="FFFFFF"/>
                     </a:solidFill>
@@ -9333,7 +9770,7 @@
                       </a:r>
                     </a:p>
                   </a:txBody>
-                  <a:tcPr marL="109728" marR="109728" marT="45720" marB="45720">
+                  <a:tcPr marL="109728" marR="109728">
                     <a:solidFill>
                       <a:srgbClr val="FFFFFF"/>
                     </a:solidFill>
@@ -9355,12 +9792,17 @@
                       </a:r>
                     </a:p>
                   </a:txBody>
-                  <a:tcPr marL="109728" marR="109728" marT="45720" marB="45720">
+                  <a:tcPr marL="109728" marR="109728">
                     <a:solidFill>
                       <a:srgbClr val="FFFFFF"/>
                     </a:solidFill>
                   </a:tcPr>
                 </a:tc>
+                <a:extLst>
+                  <a:ext uri="{0D108BD9-81ED-4DB2-BD59-A6C34878D82A}">
+                    <a16:rowId xmlns:a16="http://schemas.microsoft.com/office/drawing/2014/main" val="10003"/>
+                  </a:ext>
+                </a:extLst>
               </a:tr>
               <a:tr h="518160">
                 <a:tc>
@@ -9379,7 +9821,7 @@
                       </a:r>
                     </a:p>
                   </a:txBody>
-                  <a:tcPr marL="109728" marR="109728" marT="45720" marB="45720">
+                  <a:tcPr marL="109728" marR="109728">
                     <a:solidFill>
                       <a:srgbClr val="FAFAFA"/>
                     </a:solidFill>
@@ -9401,7 +9843,7 @@
                       </a:r>
                     </a:p>
                   </a:txBody>
-                  <a:tcPr marL="109728" marR="109728" marT="45720" marB="45720">
+                  <a:tcPr marL="109728" marR="109728">
                     <a:solidFill>
                       <a:srgbClr val="FAFAFA"/>
                     </a:solidFill>
@@ -9423,12 +9865,17 @@
                       </a:r>
                     </a:p>
                   </a:txBody>
-                  <a:tcPr marL="109728" marR="109728" marT="45720" marB="45720">
+                  <a:tcPr marL="109728" marR="109728">
                     <a:solidFill>
                       <a:srgbClr val="FAFAFA"/>
                     </a:solidFill>
                   </a:tcPr>
                 </a:tc>
+                <a:extLst>
+                  <a:ext uri="{0D108BD9-81ED-4DB2-BD59-A6C34878D82A}">
+                    <a16:rowId xmlns:a16="http://schemas.microsoft.com/office/drawing/2014/main" val="10004"/>
+                  </a:ext>
+                </a:extLst>
               </a:tr>
               <a:tr h="518160">
                 <a:tc>
@@ -9447,7 +9894,7 @@
                       </a:r>
                     </a:p>
                   </a:txBody>
-                  <a:tcPr marL="109728" marR="109728" marT="45720" marB="45720">
+                  <a:tcPr marL="109728" marR="109728">
                     <a:solidFill>
                       <a:srgbClr val="FFFFFF"/>
                     </a:solidFill>
@@ -9469,7 +9916,7 @@
                       </a:r>
                     </a:p>
                   </a:txBody>
-                  <a:tcPr marL="109728" marR="109728" marT="45720" marB="45720">
+                  <a:tcPr marL="109728" marR="109728">
                     <a:solidFill>
                       <a:srgbClr val="FFFFFF"/>
                     </a:solidFill>
@@ -9491,12 +9938,17 @@
                       </a:r>
                     </a:p>
                   </a:txBody>
-                  <a:tcPr marL="109728" marR="109728" marT="45720" marB="45720">
+                  <a:tcPr marL="109728" marR="109728">
                     <a:solidFill>
                       <a:srgbClr val="FFFFFF"/>
                     </a:solidFill>
                   </a:tcPr>
                 </a:tc>
+                <a:extLst>
+                  <a:ext uri="{0D108BD9-81ED-4DB2-BD59-A6C34878D82A}">
+                    <a16:rowId xmlns:a16="http://schemas.microsoft.com/office/drawing/2014/main" val="10005"/>
+                  </a:ext>
+                </a:extLst>
               </a:tr>
             </a:tbl>
           </a:graphicData>
@@ -9519,7 +9971,7 @@
           <a:noFill/>
         </p:spPr>
         <p:txBody>
-          <a:bodyPr wrap="square" lIns="0" rIns="0" tIns="0" bIns="0" anchor="t">
+          <a:bodyPr wrap="square" lIns="0" tIns="0" rIns="0" bIns="0" anchor="t">
             <a:spAutoFit/>
           </a:bodyPr>
           <a:lstStyle/>
@@ -9546,7 +9998,7 @@
 </file>
 
 <file path=ppt/slides/slide4.xml><?xml version="1.0" encoding="utf-8"?>
-<p:sld xmlns:a="http://schemas.openxmlformats.org/drawingml/2006/main" xmlns:p="http://schemas.openxmlformats.org/presentationml/2006/main" xmlns:r="http://schemas.openxmlformats.org/officeDocument/2006/relationships">
+<p:sld xmlns:a="http://schemas.openxmlformats.org/drawingml/2006/main" xmlns:r="http://schemas.openxmlformats.org/officeDocument/2006/relationships" xmlns:p="http://schemas.openxmlformats.org/presentationml/2006/main">
   <p:cSld>
     <p:spTree>
       <p:nvGrpSpPr>
@@ -9554,7 +10006,14 @@
         <p:cNvGrpSpPr/>
         <p:nvPr/>
       </p:nvGrpSpPr>
-      <p:grpSpPr/>
+      <p:grpSpPr>
+        <a:xfrm>
+          <a:off x="0" y="0"/>
+          <a:ext cx="0" cy="0"/>
+          <a:chOff x="0" y="0"/>
+          <a:chExt cx="0" cy="0"/>
+        </a:xfrm>
+      </p:grpSpPr>
       <p:sp>
         <p:nvSpPr>
           <p:cNvPr id="2" name="Rectangle 1"/>
@@ -9596,6 +10055,7 @@
           <a:lstStyle/>
           <a:p>
             <a:pPr algn="ctr"/>
+            <a:endParaRPr/>
           </a:p>
         </p:txBody>
       </p:sp>
@@ -9616,7 +10076,7 @@
           <a:noFill/>
         </p:spPr>
         <p:txBody>
-          <a:bodyPr wrap="square" lIns="0" rIns="0" tIns="0" bIns="0" anchor="t">
+          <a:bodyPr wrap="square" lIns="0" tIns="0" rIns="0" bIns="0" anchor="t">
             <a:spAutoFit/>
           </a:bodyPr>
           <a:lstStyle/>
@@ -9651,7 +10111,7 @@
           <a:noFill/>
         </p:spPr>
         <p:txBody>
-          <a:bodyPr wrap="square" lIns="0" rIns="0" tIns="0" bIns="0" anchor="t">
+          <a:bodyPr wrap="square" lIns="0" tIns="0" rIns="0" bIns="0" anchor="t">
             <a:spAutoFit/>
           </a:bodyPr>
           <a:lstStyle/>
@@ -9686,7 +10146,7 @@
           <a:noFill/>
         </p:spPr>
         <p:txBody>
-          <a:bodyPr wrap="square" lIns="0" rIns="0" tIns="0" bIns="0" anchor="t">
+          <a:bodyPr wrap="square" lIns="0" tIns="0" rIns="0" bIns="0" anchor="t">
             <a:spAutoFit/>
           </a:bodyPr>
           <a:lstStyle/>
@@ -9721,7 +10181,7 @@
           <a:noFill/>
         </p:spPr>
         <p:txBody>
-          <a:bodyPr wrap="square" lIns="0" rIns="0" tIns="0" bIns="0" anchor="t">
+          <a:bodyPr wrap="square" lIns="0" tIns="0" rIns="0" bIns="0" anchor="t">
             <a:spAutoFit/>
           </a:bodyPr>
           <a:lstStyle/>
@@ -9756,7 +10216,7 @@
           <a:noFill/>
         </p:spPr>
         <p:txBody>
-          <a:bodyPr wrap="square" lIns="0" rIns="0" tIns="0" bIns="0" anchor="t">
+          <a:bodyPr wrap="square" lIns="0" tIns="0" rIns="0" bIns="0" anchor="t">
             <a:spAutoFit/>
           </a:bodyPr>
           <a:lstStyle/>
@@ -9791,7 +10251,7 @@
           <a:noFill/>
         </p:spPr>
         <p:txBody>
-          <a:bodyPr wrap="square" lIns="0" rIns="0" tIns="0" bIns="0" anchor="ctr">
+          <a:bodyPr wrap="square" lIns="0" tIns="0" rIns="0" bIns="0" anchor="ctr">
             <a:spAutoFit/>
           </a:bodyPr>
           <a:lstStyle/>
@@ -9850,6 +10310,7 @@
           <a:lstStyle/>
           <a:p>
             <a:pPr algn="ctr"/>
+            <a:endParaRPr/>
           </a:p>
         </p:txBody>
       </p:sp>
@@ -9863,7 +10324,7 @@
         </p:nvGraphicFramePr>
         <p:xfrm>
           <a:off x="640080" y="2057400"/>
-          <a:ext cx="10911535" cy="2560320"/>
+          <a:ext cx="10911535" cy="2627376"/>
         </p:xfrm>
         <a:graphic>
           <a:graphicData uri="http://schemas.openxmlformats.org/drawingml/2006/table">
@@ -9872,9 +10333,27 @@
                 <a:tableStyleId>{5C22544A-7EE6-4342-B048-85BDC9FD1C3A}</a:tableStyleId>
               </a:tblPr>
               <a:tblGrid>
-                <a:gridCol w="3637178"/>
-                <a:gridCol w="3637178"/>
-                <a:gridCol w="3637179"/>
+                <a:gridCol w="3637178">
+                  <a:extLst>
+                    <a:ext uri="{9D8B030D-6E8A-4147-A177-3AD203B41FA5}">
+                      <a16:colId xmlns:a16="http://schemas.microsoft.com/office/drawing/2014/main" val="20000"/>
+                    </a:ext>
+                  </a:extLst>
+                </a:gridCol>
+                <a:gridCol w="3637178">
+                  <a:extLst>
+                    <a:ext uri="{9D8B030D-6E8A-4147-A177-3AD203B41FA5}">
+                      <a16:colId xmlns:a16="http://schemas.microsoft.com/office/drawing/2014/main" val="20001"/>
+                    </a:ext>
+                  </a:extLst>
+                </a:gridCol>
+                <a:gridCol w="3637179">
+                  <a:extLst>
+                    <a:ext uri="{9D8B030D-6E8A-4147-A177-3AD203B41FA5}">
+                      <a16:colId xmlns:a16="http://schemas.microsoft.com/office/drawing/2014/main" val="20002"/>
+                    </a:ext>
+                  </a:extLst>
+                </a:gridCol>
               </a:tblGrid>
               <a:tr h="512064">
                 <a:tc>
@@ -9943,6 +10422,11 @@
                     </a:solidFill>
                   </a:tcPr>
                 </a:tc>
+                <a:extLst>
+                  <a:ext uri="{0D108BD9-81ED-4DB2-BD59-A6C34878D82A}">
+                    <a16:rowId xmlns:a16="http://schemas.microsoft.com/office/drawing/2014/main" val="10000"/>
+                  </a:ext>
+                </a:extLst>
               </a:tr>
               <a:tr h="512064">
                 <a:tc>
@@ -9961,7 +10445,7 @@
                       </a:r>
                     </a:p>
                   </a:txBody>
-                  <a:tcPr marL="109728" marR="109728" marT="45720" marB="45720">
+                  <a:tcPr marL="109728" marR="109728">
                     <a:solidFill>
                       <a:srgbClr val="FFFFFF"/>
                     </a:solidFill>
@@ -9983,7 +10467,7 @@
                       </a:r>
                     </a:p>
                   </a:txBody>
-                  <a:tcPr marL="109728" marR="109728" marT="45720" marB="45720">
+                  <a:tcPr marL="109728" marR="109728">
                     <a:solidFill>
                       <a:srgbClr val="FFFFFF"/>
                     </a:solidFill>
@@ -10005,12 +10489,17 @@
                       </a:r>
                     </a:p>
                   </a:txBody>
-                  <a:tcPr marL="109728" marR="109728" marT="45720" marB="45720">
+                  <a:tcPr marL="109728" marR="109728">
                     <a:solidFill>
                       <a:srgbClr val="FFFFFF"/>
                     </a:solidFill>
                   </a:tcPr>
                 </a:tc>
+                <a:extLst>
+                  <a:ext uri="{0D108BD9-81ED-4DB2-BD59-A6C34878D82A}">
+                    <a16:rowId xmlns:a16="http://schemas.microsoft.com/office/drawing/2014/main" val="10001"/>
+                  </a:ext>
+                </a:extLst>
               </a:tr>
               <a:tr h="512064">
                 <a:tc>
@@ -10029,7 +10518,7 @@
                       </a:r>
                     </a:p>
                   </a:txBody>
-                  <a:tcPr marL="109728" marR="109728" marT="45720" marB="45720">
+                  <a:tcPr marL="109728" marR="109728">
                     <a:solidFill>
                       <a:srgbClr val="FAFAFA"/>
                     </a:solidFill>
@@ -10051,7 +10540,7 @@
                       </a:r>
                     </a:p>
                   </a:txBody>
-                  <a:tcPr marL="109728" marR="109728" marT="45720" marB="45720">
+                  <a:tcPr marL="109728" marR="109728">
                     <a:solidFill>
                       <a:srgbClr val="FAFAFA"/>
                     </a:solidFill>
@@ -10073,12 +10562,17 @@
                       </a:r>
                     </a:p>
                   </a:txBody>
-                  <a:tcPr marL="109728" marR="109728" marT="45720" marB="45720">
+                  <a:tcPr marL="109728" marR="109728">
                     <a:solidFill>
                       <a:srgbClr val="FAFAFA"/>
                     </a:solidFill>
                   </a:tcPr>
                 </a:tc>
+                <a:extLst>
+                  <a:ext uri="{0D108BD9-81ED-4DB2-BD59-A6C34878D82A}">
+                    <a16:rowId xmlns:a16="http://schemas.microsoft.com/office/drawing/2014/main" val="10002"/>
+                  </a:ext>
+                </a:extLst>
               </a:tr>
               <a:tr h="512064">
                 <a:tc>
@@ -10097,7 +10591,7 @@
                       </a:r>
                     </a:p>
                   </a:txBody>
-                  <a:tcPr marL="109728" marR="109728" marT="45720" marB="45720">
+                  <a:tcPr marL="109728" marR="109728">
                     <a:solidFill>
                       <a:srgbClr val="FFFFFF"/>
                     </a:solidFill>
@@ -10119,7 +10613,7 @@
                       </a:r>
                     </a:p>
                   </a:txBody>
-                  <a:tcPr marL="109728" marR="109728" marT="45720" marB="45720">
+                  <a:tcPr marL="109728" marR="109728">
                     <a:solidFill>
                       <a:srgbClr val="FFFFFF"/>
                     </a:solidFill>
@@ -10141,12 +10635,17 @@
                       </a:r>
                     </a:p>
                   </a:txBody>
-                  <a:tcPr marL="109728" marR="109728" marT="45720" marB="45720">
+                  <a:tcPr marL="109728" marR="109728">
                     <a:solidFill>
                       <a:srgbClr val="FFFFFF"/>
                     </a:solidFill>
                   </a:tcPr>
                 </a:tc>
+                <a:extLst>
+                  <a:ext uri="{0D108BD9-81ED-4DB2-BD59-A6C34878D82A}">
+                    <a16:rowId xmlns:a16="http://schemas.microsoft.com/office/drawing/2014/main" val="10003"/>
+                  </a:ext>
+                </a:extLst>
               </a:tr>
               <a:tr h="512064">
                 <a:tc>
@@ -10165,7 +10664,7 @@
                       </a:r>
                     </a:p>
                   </a:txBody>
-                  <a:tcPr marL="109728" marR="109728" marT="45720" marB="45720">
+                  <a:tcPr marL="109728" marR="109728">
                     <a:solidFill>
                       <a:srgbClr val="FAFAFA"/>
                     </a:solidFill>
@@ -10187,7 +10686,7 @@
                       </a:r>
                     </a:p>
                   </a:txBody>
-                  <a:tcPr marL="109728" marR="109728" marT="45720" marB="45720">
+                  <a:tcPr marL="109728" marR="109728">
                     <a:solidFill>
                       <a:srgbClr val="FAFAFA"/>
                     </a:solidFill>
@@ -10209,12 +10708,17 @@
                       </a:r>
                     </a:p>
                   </a:txBody>
-                  <a:tcPr marL="109728" marR="109728" marT="45720" marB="45720">
+                  <a:tcPr marL="109728" marR="109728">
                     <a:solidFill>
                       <a:srgbClr val="FAFAFA"/>
                     </a:solidFill>
                   </a:tcPr>
                 </a:tc>
+                <a:extLst>
+                  <a:ext uri="{0D108BD9-81ED-4DB2-BD59-A6C34878D82A}">
+                    <a16:rowId xmlns:a16="http://schemas.microsoft.com/office/drawing/2014/main" val="10004"/>
+                  </a:ext>
+                </a:extLst>
               </a:tr>
             </a:tbl>
           </a:graphicData>
@@ -10237,7 +10741,7 @@
           <a:noFill/>
         </p:spPr>
         <p:txBody>
-          <a:bodyPr wrap="square" lIns="0" rIns="0" tIns="0" bIns="0" anchor="t">
+          <a:bodyPr wrap="square" lIns="0" tIns="0" rIns="0" bIns="0" anchor="t">
             <a:spAutoFit/>
           </a:bodyPr>
           <a:lstStyle/>
@@ -10264,7 +10768,7 @@
 </file>
 
 <file path=ppt/slides/slide5.xml><?xml version="1.0" encoding="utf-8"?>
-<p:sld xmlns:a="http://schemas.openxmlformats.org/drawingml/2006/main" xmlns:p="http://schemas.openxmlformats.org/presentationml/2006/main" xmlns:r="http://schemas.openxmlformats.org/officeDocument/2006/relationships">
+<p:sld xmlns:a="http://schemas.openxmlformats.org/drawingml/2006/main" xmlns:r="http://schemas.openxmlformats.org/officeDocument/2006/relationships" xmlns:p="http://schemas.openxmlformats.org/presentationml/2006/main">
   <p:cSld>
     <p:spTree>
       <p:nvGrpSpPr>
@@ -10272,7 +10776,14 @@
         <p:cNvGrpSpPr/>
         <p:nvPr/>
       </p:nvGrpSpPr>
-      <p:grpSpPr/>
+      <p:grpSpPr>
+        <a:xfrm>
+          <a:off x="0" y="0"/>
+          <a:ext cx="0" cy="0"/>
+          <a:chOff x="0" y="0"/>
+          <a:chExt cx="0" cy="0"/>
+        </a:xfrm>
+      </p:grpSpPr>
       <p:sp>
         <p:nvSpPr>
           <p:cNvPr id="2" name="Rectangle 1"/>
@@ -10314,6 +10825,7 @@
           <a:lstStyle/>
           <a:p>
             <a:pPr algn="ctr"/>
+            <a:endParaRPr/>
           </a:p>
         </p:txBody>
       </p:sp>
@@ -10334,7 +10846,7 @@
           <a:noFill/>
         </p:spPr>
         <p:txBody>
-          <a:bodyPr wrap="square" lIns="0" rIns="0" tIns="0" bIns="0" anchor="t">
+          <a:bodyPr wrap="square" lIns="0" tIns="0" rIns="0" bIns="0" anchor="t">
             <a:spAutoFit/>
           </a:bodyPr>
           <a:lstStyle/>
@@ -10369,7 +10881,7 @@
           <a:noFill/>
         </p:spPr>
         <p:txBody>
-          <a:bodyPr wrap="square" lIns="0" rIns="0" tIns="0" bIns="0" anchor="t">
+          <a:bodyPr wrap="square" lIns="0" tIns="0" rIns="0" bIns="0" anchor="t">
             <a:spAutoFit/>
           </a:bodyPr>
           <a:lstStyle/>
@@ -10404,7 +10916,7 @@
           <a:noFill/>
         </p:spPr>
         <p:txBody>
-          <a:bodyPr wrap="square" lIns="0" rIns="0" tIns="0" bIns="0" anchor="t">
+          <a:bodyPr wrap="square" lIns="0" tIns="0" rIns="0" bIns="0" anchor="t">
             <a:spAutoFit/>
           </a:bodyPr>
           <a:lstStyle/>
@@ -10439,7 +10951,7 @@
           <a:noFill/>
         </p:spPr>
         <p:txBody>
-          <a:bodyPr wrap="square" lIns="0" rIns="0" tIns="0" bIns="0" anchor="t">
+          <a:bodyPr wrap="square" lIns="0" tIns="0" rIns="0" bIns="0" anchor="t">
             <a:spAutoFit/>
           </a:bodyPr>
           <a:lstStyle/>
@@ -10474,7 +10986,7 @@
           <a:noFill/>
         </p:spPr>
         <p:txBody>
-          <a:bodyPr wrap="square" lIns="0" rIns="0" tIns="0" bIns="0" anchor="t">
+          <a:bodyPr wrap="square" lIns="0" tIns="0" rIns="0" bIns="0" anchor="t">
             <a:spAutoFit/>
           </a:bodyPr>
           <a:lstStyle/>
@@ -10509,7 +11021,7 @@
           <a:noFill/>
         </p:spPr>
         <p:txBody>
-          <a:bodyPr wrap="square" lIns="0" rIns="0" tIns="0" bIns="0" anchor="ctr">
+          <a:bodyPr wrap="square" lIns="0" tIns="0" rIns="0" bIns="0" anchor="ctr">
             <a:spAutoFit/>
           </a:bodyPr>
           <a:lstStyle/>
@@ -10568,6 +11080,7 @@
           <a:lstStyle/>
           <a:p>
             <a:pPr algn="ctr"/>
+            <a:endParaRPr/>
           </a:p>
         </p:txBody>
       </p:sp>
@@ -10588,7 +11101,7 @@
           <a:noFill/>
         </p:spPr>
         <p:txBody>
-          <a:bodyPr wrap="square" lIns="0" rIns="0" tIns="0" bIns="0" anchor="t">
+          <a:bodyPr wrap="square" lIns="0" tIns="0" rIns="0" bIns="0" anchor="t">
             <a:spAutoFit/>
           </a:bodyPr>
           <a:lstStyle/>
@@ -10623,7 +11136,7 @@
           <a:noFill/>
         </p:spPr>
         <p:txBody>
-          <a:bodyPr wrap="square" lIns="0" rIns="0" tIns="0" bIns="0" anchor="t">
+          <a:bodyPr wrap="square" lIns="0" tIns="0" rIns="0" bIns="0" anchor="t">
             <a:spAutoFit/>
           </a:bodyPr>
           <a:lstStyle/>
@@ -10658,7 +11171,7 @@
           <a:noFill/>
         </p:spPr>
         <p:txBody>
-          <a:bodyPr wrap="square" lIns="0" rIns="0" tIns="0" bIns="0" anchor="t">
+          <a:bodyPr wrap="square" lIns="0" tIns="0" rIns="0" bIns="0" anchor="t">
             <a:spAutoFit/>
           </a:bodyPr>
           <a:lstStyle/>
@@ -10792,7 +11305,7 @@
           <a:noFill/>
         </p:spPr>
         <p:txBody>
-          <a:bodyPr wrap="square" lIns="0" rIns="0" tIns="0" bIns="0" anchor="t">
+          <a:bodyPr wrap="square" lIns="0" tIns="0" rIns="0" bIns="0" anchor="t">
             <a:spAutoFit/>
           </a:bodyPr>
           <a:lstStyle/>
@@ -10899,7 +11412,7 @@
 </file>
 
 <file path=ppt/slides/slide6.xml><?xml version="1.0" encoding="utf-8"?>
-<p:sld xmlns:a="http://schemas.openxmlformats.org/drawingml/2006/main" xmlns:p="http://schemas.openxmlformats.org/presentationml/2006/main" xmlns:r="http://schemas.openxmlformats.org/officeDocument/2006/relationships">
+<p:sld xmlns:a="http://schemas.openxmlformats.org/drawingml/2006/main" xmlns:r="http://schemas.openxmlformats.org/officeDocument/2006/relationships" xmlns:p="http://schemas.openxmlformats.org/presentationml/2006/main">
   <p:cSld>
     <p:spTree>
       <p:nvGrpSpPr>
@@ -10907,7 +11420,14 @@
         <p:cNvGrpSpPr/>
         <p:nvPr/>
       </p:nvGrpSpPr>
-      <p:grpSpPr/>
+      <p:grpSpPr>
+        <a:xfrm>
+          <a:off x="0" y="0"/>
+          <a:ext cx="0" cy="0"/>
+          <a:chOff x="0" y="0"/>
+          <a:chExt cx="0" cy="0"/>
+        </a:xfrm>
+      </p:grpSpPr>
       <p:sp>
         <p:nvSpPr>
           <p:cNvPr id="2" name="Rectangle 1"/>
@@ -10949,6 +11469,7 @@
           <a:lstStyle/>
           <a:p>
             <a:pPr algn="ctr"/>
+            <a:endParaRPr/>
           </a:p>
         </p:txBody>
       </p:sp>
@@ -10993,6 +11514,7 @@
           <a:lstStyle/>
           <a:p>
             <a:pPr algn="ctr"/>
+            <a:endParaRPr/>
           </a:p>
         </p:txBody>
       </p:sp>
@@ -11013,7 +11535,7 @@
           <a:noFill/>
         </p:spPr>
         <p:txBody>
-          <a:bodyPr wrap="square" lIns="0" rIns="0" tIns="0" bIns="0" anchor="t">
+          <a:bodyPr wrap="square" lIns="0" tIns="0" rIns="0" bIns="0" anchor="t">
             <a:spAutoFit/>
           </a:bodyPr>
           <a:lstStyle/>
@@ -11048,7 +11570,7 @@
           <a:noFill/>
         </p:spPr>
         <p:txBody>
-          <a:bodyPr wrap="square" lIns="0" rIns="0" tIns="0" bIns="0" anchor="t">
+          <a:bodyPr wrap="square" lIns="0" tIns="0" rIns="0" bIns="0" anchor="t">
             <a:spAutoFit/>
           </a:bodyPr>
           <a:lstStyle/>
@@ -11083,7 +11605,7 @@
           <a:noFill/>
         </p:spPr>
         <p:txBody>
-          <a:bodyPr wrap="square" lIns="0" rIns="0" tIns="0" bIns="0" anchor="t">
+          <a:bodyPr wrap="square" lIns="0" tIns="0" rIns="0" bIns="0" anchor="t">
             <a:spAutoFit/>
           </a:bodyPr>
           <a:lstStyle/>
@@ -11118,7 +11640,7 @@
           <a:noFill/>
         </p:spPr>
         <p:txBody>
-          <a:bodyPr wrap="square" lIns="0" rIns="0" tIns="0" bIns="0" anchor="t">
+          <a:bodyPr wrap="square" lIns="0" tIns="0" rIns="0" bIns="0" anchor="t">
             <a:spAutoFit/>
           </a:bodyPr>
           <a:lstStyle/>
@@ -11153,7 +11675,7 @@
           <a:noFill/>
         </p:spPr>
         <p:txBody>
-          <a:bodyPr wrap="square" lIns="0" rIns="0" tIns="0" bIns="0" anchor="t">
+          <a:bodyPr wrap="square" lIns="0" tIns="0" rIns="0" bIns="0" anchor="t">
             <a:spAutoFit/>
           </a:bodyPr>
           <a:lstStyle/>
@@ -11208,7 +11730,7 @@
           </a:fontRef>
         </p:style>
         <p:txBody>
-          <a:bodyPr rtlCol="0" anchor="ctr" lIns="0" rIns="0" tIns="0" bIns="0"/>
+          <a:bodyPr lIns="0" tIns="0" rIns="0" bIns="0" rtlCol="0" anchor="ctr"/>
           <a:lstStyle/>
           <a:p>
             <a:pPr algn="ctr"/>
@@ -11261,7 +11783,7 @@
           </a:fontRef>
         </p:style>
         <p:txBody>
-          <a:bodyPr rtlCol="0" anchor="ctr" lIns="0" rIns="0" tIns="0" bIns="0"/>
+          <a:bodyPr lIns="0" tIns="0" rIns="0" bIns="0" rtlCol="0" anchor="ctr"/>
           <a:lstStyle/>
           <a:p>
             <a:pPr algn="ctr"/>
@@ -11294,7 +11816,7 @@
           <a:noFill/>
         </p:spPr>
         <p:txBody>
-          <a:bodyPr wrap="square" lIns="0" rIns="0" tIns="0" bIns="0" anchor="t">
+          <a:bodyPr wrap="square" lIns="0" tIns="0" rIns="0" bIns="0" anchor="t">
             <a:spAutoFit/>
           </a:bodyPr>
           <a:lstStyle/>
@@ -11329,7 +11851,7 @@
           <a:noFill/>
         </p:spPr>
         <p:txBody>
-          <a:bodyPr wrap="square" lIns="0" rIns="0" tIns="0" bIns="0" anchor="t">
+          <a:bodyPr wrap="square" lIns="0" tIns="0" rIns="0" bIns="0" anchor="t">
             <a:spAutoFit/>
           </a:bodyPr>
           <a:lstStyle/>
@@ -11340,13 +11862,31 @@
               </a:lnSpc>
             </a:pPr>
             <a:r>
-              <a:rPr sz="1700" b="0" i="0">
+              <a:rPr sz="1700" b="0" i="0" dirty="0">
                 <a:solidFill>
                   <a:srgbClr val="F3F2F1"/>
                 </a:solidFill>
                 <a:latin typeface="Segoe UI"/>
               </a:rPr>
-              <a:t>Um prompt agent chamado finance-orchestrator.</a:t>
+              <a:t>Um prompt agent </a:t>
+            </a:r>
+            <a:r>
+              <a:rPr sz="1700" b="0" i="0" dirty="0" err="1">
+                <a:solidFill>
+                  <a:srgbClr val="F3F2F1"/>
+                </a:solidFill>
+                <a:latin typeface="Segoe UI"/>
+              </a:rPr>
+              <a:t>chamado</a:t>
+            </a:r>
+            <a:r>
+              <a:rPr sz="1700" b="0" i="0" dirty="0">
+                <a:solidFill>
+                  <a:srgbClr val="F3F2F1"/>
+                </a:solidFill>
+                <a:latin typeface="Segoe UI"/>
+              </a:rPr>
+              <a:t> finance-orchestrator.</a:t>
             </a:r>
           </a:p>
           <a:p>
@@ -11359,13 +11899,49 @@
               </a:spcBef>
             </a:pPr>
             <a:r>
-              <a:rPr sz="1700" b="0" i="0">
+              <a:rPr sz="1700" b="0" i="0" dirty="0">
                 <a:solidFill>
                   <a:srgbClr val="F3F2F1"/>
                 </a:solidFill>
                 <a:latin typeface="Segoe UI"/>
               </a:rPr>
-              <a:t>Seis tools MCP, expostas via APIM AI Gateway, vindas do registry.</a:t>
+              <a:t>Seis tools MCP, </a:t>
+            </a:r>
+            <a:r>
+              <a:rPr sz="1700" b="0" i="0" dirty="0" err="1">
+                <a:solidFill>
+                  <a:srgbClr val="F3F2F1"/>
+                </a:solidFill>
+                <a:latin typeface="Segoe UI"/>
+              </a:rPr>
+              <a:t>expostas</a:t>
+            </a:r>
+            <a:r>
+              <a:rPr sz="1700" b="0" i="0" dirty="0">
+                <a:solidFill>
+                  <a:srgbClr val="F3F2F1"/>
+                </a:solidFill>
+                <a:latin typeface="Segoe UI"/>
+              </a:rPr>
+              <a:t> via APIM AI Gateway, </a:t>
+            </a:r>
+            <a:r>
+              <a:rPr sz="1700" b="0" i="0" dirty="0" err="1">
+                <a:solidFill>
+                  <a:srgbClr val="F3F2F1"/>
+                </a:solidFill>
+                <a:latin typeface="Segoe UI"/>
+              </a:rPr>
+              <a:t>vindas</a:t>
+            </a:r>
+            <a:r>
+              <a:rPr sz="1700" b="0" i="0" dirty="0">
+                <a:solidFill>
+                  <a:srgbClr val="F3F2F1"/>
+                </a:solidFill>
+                <a:latin typeface="Segoe UI"/>
+              </a:rPr>
+              <a:t> do registry.</a:t>
             </a:r>
           </a:p>
           <a:p>
@@ -11378,13 +11954,103 @@
               </a:spcBef>
             </a:pPr>
             <a:r>
-              <a:rPr sz="1700" b="0" i="0">
+              <a:rPr sz="1700" b="0" i="0" dirty="0">
                 <a:solidFill>
                   <a:srgbClr val="F3F2F1"/>
                 </a:solidFill>
                 <a:latin typeface="Segoe UI"/>
               </a:rPr>
-              <a:t>Um turno: “quero reembolso de USD 1800 para visitar um cliente novo”.</a:t>
+              <a:t>Um </a:t>
+            </a:r>
+            <a:r>
+              <a:rPr sz="1700" b="0" i="0" dirty="0" err="1">
+                <a:solidFill>
+                  <a:srgbClr val="F3F2F1"/>
+                </a:solidFill>
+                <a:latin typeface="Segoe UI"/>
+              </a:rPr>
+              <a:t>turno</a:t>
+            </a:r>
+            <a:r>
+              <a:rPr sz="1700" b="0" i="0" dirty="0">
+                <a:solidFill>
+                  <a:srgbClr val="F3F2F1"/>
+                </a:solidFill>
+                <a:latin typeface="Segoe UI"/>
+              </a:rPr>
+              <a:t>: “</a:t>
+            </a:r>
+            <a:r>
+              <a:rPr sz="1700" b="0" i="0" dirty="0" err="1">
+                <a:solidFill>
+                  <a:srgbClr val="F3F2F1"/>
+                </a:solidFill>
+                <a:latin typeface="Segoe UI"/>
+              </a:rPr>
+              <a:t>quero</a:t>
+            </a:r>
+            <a:r>
+              <a:rPr sz="1700" b="0" i="0" dirty="0">
+                <a:solidFill>
+                  <a:srgbClr val="F3F2F1"/>
+                </a:solidFill>
+                <a:latin typeface="Segoe UI"/>
+              </a:rPr>
+              <a:t> </a:t>
+            </a:r>
+            <a:r>
+              <a:rPr sz="1700" b="0" i="0" dirty="0" err="1">
+                <a:solidFill>
+                  <a:srgbClr val="F3F2F1"/>
+                </a:solidFill>
+                <a:latin typeface="Segoe UI"/>
+              </a:rPr>
+              <a:t>reembolso</a:t>
+            </a:r>
+            <a:r>
+              <a:rPr sz="1700" b="0" i="0" dirty="0">
+                <a:solidFill>
+                  <a:srgbClr val="F3F2F1"/>
+                </a:solidFill>
+                <a:latin typeface="Segoe UI"/>
+              </a:rPr>
+              <a:t> de USD 1800 para </a:t>
+            </a:r>
+            <a:r>
+              <a:rPr sz="1700" b="0" i="0" dirty="0" err="1">
+                <a:solidFill>
+                  <a:srgbClr val="F3F2F1"/>
+                </a:solidFill>
+                <a:latin typeface="Segoe UI"/>
+              </a:rPr>
+              <a:t>visitar</a:t>
+            </a:r>
+            <a:r>
+              <a:rPr sz="1700" b="0" i="0" dirty="0">
+                <a:solidFill>
+                  <a:srgbClr val="F3F2F1"/>
+                </a:solidFill>
+                <a:latin typeface="Segoe UI"/>
+              </a:rPr>
+              <a:t> um </a:t>
+            </a:r>
+            <a:r>
+              <a:rPr sz="1700" b="0" i="0" dirty="0" err="1">
+                <a:solidFill>
+                  <a:srgbClr val="F3F2F1"/>
+                </a:solidFill>
+                <a:latin typeface="Segoe UI"/>
+              </a:rPr>
+              <a:t>cliente</a:t>
+            </a:r>
+            <a:r>
+              <a:rPr sz="1700" b="0" i="0" dirty="0">
+                <a:solidFill>
+                  <a:srgbClr val="F3F2F1"/>
+                </a:solidFill>
+                <a:latin typeface="Segoe UI"/>
+              </a:rPr>
+              <a:t> novo”.</a:t>
             </a:r>
           </a:p>
           <a:p>
@@ -11397,13 +12063,175 @@
               </a:spcBef>
             </a:pPr>
             <a:r>
-              <a:rPr sz="1700" b="0" i="0">
+              <a:rPr sz="1700" b="0" i="0" dirty="0">
                 <a:solidFill>
                   <a:srgbClr val="F3F2F1"/>
                 </a:solidFill>
                 <a:latin typeface="Segoe UI"/>
               </a:rPr>
-              <a:t>Tool calls aparecem em sequência: policy_lookup → permission_check → document_search → justification_draft → ticket_open → evidence_log.</a:t>
+              <a:t>Tool calls </a:t>
+            </a:r>
+            <a:r>
+              <a:rPr sz="1700" b="0" i="0" dirty="0" err="1">
+                <a:solidFill>
+                  <a:srgbClr val="F3F2F1"/>
+                </a:solidFill>
+                <a:latin typeface="Segoe UI"/>
+              </a:rPr>
+              <a:t>aparecem</a:t>
+            </a:r>
+            <a:r>
+              <a:rPr sz="1700" b="0" i="0" dirty="0">
+                <a:solidFill>
+                  <a:srgbClr val="F3F2F1"/>
+                </a:solidFill>
+                <a:latin typeface="Segoe UI"/>
+              </a:rPr>
+              <a:t> </a:t>
+            </a:r>
+            <a:r>
+              <a:rPr sz="1700" b="0" i="0" dirty="0" err="1">
+                <a:solidFill>
+                  <a:srgbClr val="F3F2F1"/>
+                </a:solidFill>
+                <a:latin typeface="Segoe UI"/>
+              </a:rPr>
+              <a:t>em</a:t>
+            </a:r>
+            <a:r>
+              <a:rPr sz="1700" b="0" i="0" dirty="0">
+                <a:solidFill>
+                  <a:srgbClr val="F3F2F1"/>
+                </a:solidFill>
+                <a:latin typeface="Segoe UI"/>
+              </a:rPr>
+              <a:t> </a:t>
+            </a:r>
+            <a:r>
+              <a:rPr sz="1700" b="0" i="0" dirty="0" err="1">
+                <a:solidFill>
+                  <a:srgbClr val="F3F2F1"/>
+                </a:solidFill>
+                <a:latin typeface="Segoe UI"/>
+              </a:rPr>
+              <a:t>sequência</a:t>
+            </a:r>
+            <a:r>
+              <a:rPr sz="1700" b="0" i="0" dirty="0">
+                <a:solidFill>
+                  <a:srgbClr val="F3F2F1"/>
+                </a:solidFill>
+                <a:latin typeface="Segoe UI"/>
+              </a:rPr>
+              <a:t>: </a:t>
+            </a:r>
+            <a:r>
+              <a:rPr sz="1700" b="0" i="0" dirty="0" err="1">
+                <a:solidFill>
+                  <a:srgbClr val="F3F2F1"/>
+                </a:solidFill>
+                <a:latin typeface="Segoe UI"/>
+              </a:rPr>
+              <a:t>policy_lookup</a:t>
+            </a:r>
+            <a:r>
+              <a:rPr sz="1700" b="0" i="0" dirty="0">
+                <a:solidFill>
+                  <a:srgbClr val="F3F2F1"/>
+                </a:solidFill>
+                <a:latin typeface="Segoe UI"/>
+              </a:rPr>
+              <a:t> → </a:t>
+            </a:r>
+            <a:r>
+              <a:rPr sz="1700" b="0" i="0" dirty="0" err="1">
+                <a:solidFill>
+                  <a:srgbClr val="F3F2F1"/>
+                </a:solidFill>
+                <a:latin typeface="Segoe UI"/>
+              </a:rPr>
+              <a:t>permission_check</a:t>
+            </a:r>
+            <a:r>
+              <a:rPr sz="1700" b="0" i="0" dirty="0">
+                <a:solidFill>
+                  <a:srgbClr val="F3F2F1"/>
+                </a:solidFill>
+                <a:latin typeface="Segoe UI"/>
+              </a:rPr>
+              <a:t> → </a:t>
+            </a:r>
+            <a:r>
+              <a:rPr sz="1700" b="0" i="0" dirty="0" err="1">
+                <a:solidFill>
+                  <a:srgbClr val="F3F2F1"/>
+                </a:solidFill>
+                <a:latin typeface="Segoe UI"/>
+              </a:rPr>
+              <a:t>document_search</a:t>
+            </a:r>
+            <a:r>
+              <a:rPr sz="1700" b="0" i="0" dirty="0">
+                <a:solidFill>
+                  <a:srgbClr val="F3F2F1"/>
+                </a:solidFill>
+                <a:latin typeface="Segoe UI"/>
+              </a:rPr>
+              <a:t> → </a:t>
+            </a:r>
+            <a:r>
+              <a:rPr sz="1700" b="0" i="0" dirty="0" err="1">
+                <a:solidFill>
+                  <a:srgbClr val="F3F2F1"/>
+                </a:solidFill>
+                <a:latin typeface="Segoe UI"/>
+              </a:rPr>
+              <a:t>justification_draft</a:t>
+            </a:r>
+            <a:r>
+              <a:rPr sz="1700" b="0" i="0" dirty="0">
+                <a:solidFill>
+                  <a:srgbClr val="F3F2F1"/>
+                </a:solidFill>
+                <a:latin typeface="Segoe UI"/>
+              </a:rPr>
+              <a:t> → </a:t>
+            </a:r>
+            <a:r>
+              <a:rPr sz="1700" b="0" i="0" dirty="0" err="1">
+                <a:solidFill>
+                  <a:srgbClr val="F3F2F1"/>
+                </a:solidFill>
+                <a:latin typeface="Segoe UI"/>
+              </a:rPr>
+              <a:t>ticket_open</a:t>
+            </a:r>
+            <a:r>
+              <a:rPr sz="1700" b="0" i="0" dirty="0">
+                <a:solidFill>
+                  <a:srgbClr val="F3F2F1"/>
+                </a:solidFill>
+                <a:latin typeface="Segoe UI"/>
+              </a:rPr>
+              <a:t> → </a:t>
+            </a:r>
+            <a:r>
+              <a:rPr sz="1700" b="0" i="0" dirty="0" err="1">
+                <a:solidFill>
+                  <a:srgbClr val="F3F2F1"/>
+                </a:solidFill>
+                <a:latin typeface="Segoe UI"/>
+              </a:rPr>
+              <a:t>evidence_log</a:t>
+            </a:r>
+            <a:r>
+              <a:rPr sz="1700" b="0" i="0" dirty="0">
+                <a:solidFill>
+                  <a:srgbClr val="F3F2F1"/>
+                </a:solidFill>
+                <a:latin typeface="Segoe UI"/>
+              </a:rPr>
+              <a:t>.</a:t>
             </a:r>
           </a:p>
         </p:txBody>
@@ -11451,6 +12279,7 @@
           <a:lstStyle/>
           <a:p>
             <a:pPr algn="ctr"/>
+            <a:endParaRPr/>
           </a:p>
         </p:txBody>
       </p:sp>
@@ -11471,7 +12300,7 @@
           <a:noFill/>
         </p:spPr>
         <p:txBody>
-          <a:bodyPr wrap="square" lIns="0" rIns="0" tIns="0" bIns="0" anchor="t">
+          <a:bodyPr wrap="square" lIns="0" tIns="0" rIns="0" bIns="0" anchor="t">
             <a:spAutoFit/>
           </a:bodyPr>
           <a:lstStyle/>
@@ -11521,7 +12350,7 @@
 </file>
 
 <file path=ppt/slides/slide7.xml><?xml version="1.0" encoding="utf-8"?>
-<p:sld xmlns:a="http://schemas.openxmlformats.org/drawingml/2006/main" xmlns:p="http://schemas.openxmlformats.org/presentationml/2006/main" xmlns:r="http://schemas.openxmlformats.org/officeDocument/2006/relationships">
+<p:sld xmlns:a="http://schemas.openxmlformats.org/drawingml/2006/main" xmlns:r="http://schemas.openxmlformats.org/officeDocument/2006/relationships" xmlns:p="http://schemas.openxmlformats.org/presentationml/2006/main">
   <p:cSld>
     <p:spTree>
       <p:nvGrpSpPr>
@@ -11529,7 +12358,14 @@
         <p:cNvGrpSpPr/>
         <p:nvPr/>
       </p:nvGrpSpPr>
-      <p:grpSpPr/>
+      <p:grpSpPr>
+        <a:xfrm>
+          <a:off x="0" y="0"/>
+          <a:ext cx="0" cy="0"/>
+          <a:chOff x="0" y="0"/>
+          <a:chExt cx="0" cy="0"/>
+        </a:xfrm>
+      </p:grpSpPr>
       <p:sp>
         <p:nvSpPr>
           <p:cNvPr id="2" name="Rectangle 1"/>
@@ -11571,6 +12407,7 @@
           <a:lstStyle/>
           <a:p>
             <a:pPr algn="ctr"/>
+            <a:endParaRPr/>
           </a:p>
         </p:txBody>
       </p:sp>
@@ -11591,7 +12428,7 @@
           <a:noFill/>
         </p:spPr>
         <p:txBody>
-          <a:bodyPr wrap="square" lIns="0" rIns="0" tIns="0" bIns="0" anchor="t">
+          <a:bodyPr wrap="square" lIns="0" tIns="0" rIns="0" bIns="0" anchor="t">
             <a:spAutoFit/>
           </a:bodyPr>
           <a:lstStyle/>
@@ -11626,7 +12463,7 @@
           <a:noFill/>
         </p:spPr>
         <p:txBody>
-          <a:bodyPr wrap="square" lIns="0" rIns="0" tIns="0" bIns="0" anchor="t">
+          <a:bodyPr wrap="square" lIns="0" tIns="0" rIns="0" bIns="0" anchor="t">
             <a:spAutoFit/>
           </a:bodyPr>
           <a:lstStyle/>
@@ -11661,7 +12498,7 @@
           <a:noFill/>
         </p:spPr>
         <p:txBody>
-          <a:bodyPr wrap="square" lIns="0" rIns="0" tIns="0" bIns="0" anchor="t">
+          <a:bodyPr wrap="square" lIns="0" tIns="0" rIns="0" bIns="0" anchor="t">
             <a:spAutoFit/>
           </a:bodyPr>
           <a:lstStyle/>
@@ -11696,7 +12533,7 @@
           <a:noFill/>
         </p:spPr>
         <p:txBody>
-          <a:bodyPr wrap="square" lIns="0" rIns="0" tIns="0" bIns="0" anchor="t">
+          <a:bodyPr wrap="square" lIns="0" tIns="0" rIns="0" bIns="0" anchor="t">
             <a:spAutoFit/>
           </a:bodyPr>
           <a:lstStyle/>
@@ -11731,7 +12568,7 @@
           <a:noFill/>
         </p:spPr>
         <p:txBody>
-          <a:bodyPr wrap="square" lIns="0" rIns="0" tIns="0" bIns="0" anchor="t">
+          <a:bodyPr wrap="square" lIns="0" tIns="0" rIns="0" bIns="0" anchor="t">
             <a:spAutoFit/>
           </a:bodyPr>
           <a:lstStyle/>
@@ -11757,8 +12594,8 @@
         </p:nvSpPr>
         <p:spPr>
           <a:xfrm>
-            <a:off x="640080" y="868680"/>
-            <a:ext cx="10911535" cy="960120"/>
+            <a:off x="640080" y="1102519"/>
+            <a:ext cx="10911535" cy="492443"/>
           </a:xfrm>
           <a:prstGeom prst="rect">
             <a:avLst/>
@@ -11766,21 +12603,108 @@
           <a:noFill/>
         </p:spPr>
         <p:txBody>
-          <a:bodyPr wrap="square" lIns="0" rIns="0" tIns="0" bIns="0" anchor="ctr">
+          <a:bodyPr wrap="square" lIns="0" tIns="0" rIns="0" bIns="0" anchor="ctr">
             <a:spAutoFit/>
           </a:bodyPr>
           <a:lstStyle/>
           <a:p>
             <a:pPr algn="l"/>
             <a:r>
-              <a:rPr sz="3600" b="0" i="0">
+              <a:rPr sz="3200" b="0" i="0" dirty="0">
                 <a:solidFill>
                   <a:srgbClr val="002050"/>
                 </a:solidFill>
                 <a:latin typeface="Segoe UI Semibold"/>
               </a:rPr>
-              <a:t>O contrato — o que faz uma capability ser reutilizável</a:t>
-            </a:r>
+              <a:t>O </a:t>
+            </a:r>
+            <a:r>
+              <a:rPr sz="3200" b="0" i="0" dirty="0" err="1">
+                <a:solidFill>
+                  <a:srgbClr val="002050"/>
+                </a:solidFill>
+                <a:latin typeface="Segoe UI Semibold"/>
+              </a:rPr>
+              <a:t>contrato</a:t>
+            </a:r>
+            <a:r>
+              <a:rPr sz="3200" b="0" i="0" dirty="0">
+                <a:solidFill>
+                  <a:srgbClr val="002050"/>
+                </a:solidFill>
+                <a:latin typeface="Segoe UI Semibold"/>
+              </a:rPr>
+              <a:t> — o </a:t>
+            </a:r>
+            <a:r>
+              <a:rPr sz="3200" b="0" i="0" dirty="0" err="1">
+                <a:solidFill>
+                  <a:srgbClr val="002050"/>
+                </a:solidFill>
+                <a:latin typeface="Segoe UI Semibold"/>
+              </a:rPr>
+              <a:t>que</a:t>
+            </a:r>
+            <a:r>
+              <a:rPr sz="3200" b="0" i="0" dirty="0">
+                <a:solidFill>
+                  <a:srgbClr val="002050"/>
+                </a:solidFill>
+                <a:latin typeface="Segoe UI Semibold"/>
+              </a:rPr>
+              <a:t> </a:t>
+            </a:r>
+            <a:r>
+              <a:rPr sz="3200" b="0" i="0" dirty="0" err="1">
+                <a:solidFill>
+                  <a:srgbClr val="002050"/>
+                </a:solidFill>
+                <a:latin typeface="Segoe UI Semibold"/>
+              </a:rPr>
+              <a:t>faz</a:t>
+            </a:r>
+            <a:r>
+              <a:rPr sz="3200" b="0" i="0" dirty="0">
+                <a:solidFill>
+                  <a:srgbClr val="002050"/>
+                </a:solidFill>
+                <a:latin typeface="Segoe UI Semibold"/>
+              </a:rPr>
+              <a:t> </a:t>
+            </a:r>
+            <a:r>
+              <a:rPr sz="3200" b="0" i="0" dirty="0" err="1">
+                <a:solidFill>
+                  <a:srgbClr val="002050"/>
+                </a:solidFill>
+                <a:latin typeface="Segoe UI Semibold"/>
+              </a:rPr>
+              <a:t>uma</a:t>
+            </a:r>
+            <a:r>
+              <a:rPr sz="3200" b="0" i="0" dirty="0">
+                <a:solidFill>
+                  <a:srgbClr val="002050"/>
+                </a:solidFill>
+                <a:latin typeface="Segoe UI Semibold"/>
+              </a:rPr>
+              <a:t> capability ser </a:t>
+            </a:r>
+            <a:r>
+              <a:rPr sz="3200" b="0" i="0" dirty="0" err="1">
+                <a:solidFill>
+                  <a:srgbClr val="002050"/>
+                </a:solidFill>
+                <a:latin typeface="Segoe UI Semibold"/>
+              </a:rPr>
+              <a:t>reutilizável</a:t>
+            </a:r>
+            <a:endParaRPr sz="3200" b="0" i="0" dirty="0">
+              <a:solidFill>
+                <a:srgbClr val="002050"/>
+              </a:solidFill>
+              <a:latin typeface="Segoe UI Semibold"/>
+            </a:endParaRPr>
           </a:p>
         </p:txBody>
       </p:sp>
@@ -11825,6 +12749,7 @@
           <a:lstStyle/>
           <a:p>
             <a:pPr algn="ctr"/>
+            <a:endParaRPr/>
           </a:p>
         </p:txBody>
       </p:sp>
@@ -11845,7 +12770,7 @@
           <a:noFill/>
         </p:spPr>
         <p:txBody>
-          <a:bodyPr wrap="square" lIns="0" rIns="0" tIns="0" bIns="0" anchor="t">
+          <a:bodyPr wrap="square" lIns="0" tIns="0" rIns="0" bIns="0" anchor="t">
             <a:spAutoFit/>
           </a:bodyPr>
           <a:lstStyle/>
@@ -11904,6 +12829,7 @@
           <a:lstStyle/>
           <a:p>
             <a:pPr algn="ctr"/>
+            <a:endParaRPr/>
           </a:p>
         </p:txBody>
       </p:sp>
@@ -11924,7 +12850,7 @@
           <a:noFill/>
         </p:spPr>
         <p:txBody>
-          <a:bodyPr wrap="square" lIns="0" rIns="0" tIns="0" bIns="0" anchor="t">
+          <a:bodyPr wrap="square" lIns="0" tIns="0" rIns="0" bIns="0" anchor="t">
             <a:spAutoFit/>
           </a:bodyPr>
           <a:lstStyle/>
@@ -11964,7 +12890,7 @@
           <a:noFill/>
         </p:spPr>
         <p:txBody>
-          <a:bodyPr wrap="square" lIns="0" rIns="0" tIns="0" bIns="0" anchor="t">
+          <a:bodyPr wrap="square" lIns="0" tIns="0" rIns="0" bIns="0" anchor="t">
             <a:spAutoFit/>
           </a:bodyPr>
           <a:lstStyle/>
@@ -12052,7 +12978,7 @@
 </file>
 
 <file path=ppt/slides/slide8.xml><?xml version="1.0" encoding="utf-8"?>
-<p:sld xmlns:a="http://schemas.openxmlformats.org/drawingml/2006/main" xmlns:p="http://schemas.openxmlformats.org/presentationml/2006/main" xmlns:r="http://schemas.openxmlformats.org/officeDocument/2006/relationships">
+<p:sld xmlns:a="http://schemas.openxmlformats.org/drawingml/2006/main" xmlns:r="http://schemas.openxmlformats.org/officeDocument/2006/relationships" xmlns:p="http://schemas.openxmlformats.org/presentationml/2006/main">
   <p:cSld>
     <p:spTree>
       <p:nvGrpSpPr>
@@ -12060,7 +12986,14 @@
         <p:cNvGrpSpPr/>
         <p:nvPr/>
       </p:nvGrpSpPr>
-      <p:grpSpPr/>
+      <p:grpSpPr>
+        <a:xfrm>
+          <a:off x="0" y="0"/>
+          <a:ext cx="0" cy="0"/>
+          <a:chOff x="0" y="0"/>
+          <a:chExt cx="0" cy="0"/>
+        </a:xfrm>
+      </p:grpSpPr>
       <p:sp>
         <p:nvSpPr>
           <p:cNvPr id="2" name="Rectangle 1"/>
@@ -12102,6 +13035,7 @@
           <a:lstStyle/>
           <a:p>
             <a:pPr algn="ctr"/>
+            <a:endParaRPr/>
           </a:p>
         </p:txBody>
       </p:sp>
@@ -12122,7 +13056,7 @@
           <a:noFill/>
         </p:spPr>
         <p:txBody>
-          <a:bodyPr wrap="square" lIns="0" rIns="0" tIns="0" bIns="0" anchor="t">
+          <a:bodyPr wrap="square" lIns="0" tIns="0" rIns="0" bIns="0" anchor="t">
             <a:spAutoFit/>
           </a:bodyPr>
           <a:lstStyle/>
@@ -12157,7 +13091,7 @@
           <a:noFill/>
         </p:spPr>
         <p:txBody>
-          <a:bodyPr wrap="square" lIns="0" rIns="0" tIns="0" bIns="0" anchor="t">
+          <a:bodyPr wrap="square" lIns="0" tIns="0" rIns="0" bIns="0" anchor="t">
             <a:spAutoFit/>
           </a:bodyPr>
           <a:lstStyle/>
@@ -12192,7 +13126,7 @@
           <a:noFill/>
         </p:spPr>
         <p:txBody>
-          <a:bodyPr wrap="square" lIns="0" rIns="0" tIns="0" bIns="0" anchor="t">
+          <a:bodyPr wrap="square" lIns="0" tIns="0" rIns="0" bIns="0" anchor="t">
             <a:spAutoFit/>
           </a:bodyPr>
           <a:lstStyle/>
@@ -12227,7 +13161,7 @@
           <a:noFill/>
         </p:spPr>
         <p:txBody>
-          <a:bodyPr wrap="square" lIns="0" rIns="0" tIns="0" bIns="0" anchor="t">
+          <a:bodyPr wrap="square" lIns="0" tIns="0" rIns="0" bIns="0" anchor="t">
             <a:spAutoFit/>
           </a:bodyPr>
           <a:lstStyle/>
@@ -12262,7 +13196,7 @@
           <a:noFill/>
         </p:spPr>
         <p:txBody>
-          <a:bodyPr wrap="square" lIns="0" rIns="0" tIns="0" bIns="0" anchor="t">
+          <a:bodyPr wrap="square" lIns="0" tIns="0" rIns="0" bIns="0" anchor="t">
             <a:spAutoFit/>
           </a:bodyPr>
           <a:lstStyle/>
@@ -12297,7 +13231,7 @@
           <a:noFill/>
         </p:spPr>
         <p:txBody>
-          <a:bodyPr wrap="square" lIns="0" rIns="0" tIns="0" bIns="0" anchor="ctr">
+          <a:bodyPr wrap="square" lIns="0" tIns="0" rIns="0" bIns="0" anchor="ctr">
             <a:spAutoFit/>
           </a:bodyPr>
           <a:lstStyle/>
@@ -12356,6 +13290,7 @@
           <a:lstStyle/>
           <a:p>
             <a:pPr algn="ctr"/>
+            <a:endParaRPr/>
           </a:p>
         </p:txBody>
       </p:sp>
@@ -12400,6 +13335,7 @@
           <a:lstStyle/>
           <a:p>
             <a:pPr algn="ctr"/>
+            <a:endParaRPr/>
           </a:p>
         </p:txBody>
       </p:sp>
@@ -12420,7 +13356,7 @@
           <a:noFill/>
         </p:spPr>
         <p:txBody>
-          <a:bodyPr wrap="square" lIns="0" rIns="0" tIns="0" bIns="0" anchor="t">
+          <a:bodyPr wrap="square" lIns="0" tIns="0" rIns="0" bIns="0" anchor="t">
             <a:spAutoFit/>
           </a:bodyPr>
           <a:lstStyle/>
@@ -12459,7 +13395,7 @@
           <a:noFill/>
         </p:spPr>
         <p:txBody>
-          <a:bodyPr wrap="square" lIns="0" rIns="0" tIns="0" bIns="0" anchor="t">
+          <a:bodyPr wrap="square" lIns="0" tIns="0" rIns="0" bIns="0" anchor="t">
             <a:spAutoFit/>
           </a:bodyPr>
           <a:lstStyle/>
@@ -12518,6 +13454,7 @@
           <a:lstStyle/>
           <a:p>
             <a:pPr algn="ctr"/>
+            <a:endParaRPr/>
           </a:p>
         </p:txBody>
       </p:sp>
@@ -12562,6 +13499,7 @@
           <a:lstStyle/>
           <a:p>
             <a:pPr algn="ctr"/>
+            <a:endParaRPr/>
           </a:p>
         </p:txBody>
       </p:sp>
@@ -12582,7 +13520,7 @@
           <a:noFill/>
         </p:spPr>
         <p:txBody>
-          <a:bodyPr wrap="square" lIns="0" rIns="0" tIns="0" bIns="0" anchor="t">
+          <a:bodyPr wrap="square" lIns="0" tIns="0" rIns="0" bIns="0" anchor="t">
             <a:spAutoFit/>
           </a:bodyPr>
           <a:lstStyle/>
@@ -12609,7 +13547,7 @@
 </file>
 
 <file path=ppt/slides/slide9.xml><?xml version="1.0" encoding="utf-8"?>
-<p:sld xmlns:a="http://schemas.openxmlformats.org/drawingml/2006/main" xmlns:p="http://schemas.openxmlformats.org/presentationml/2006/main" xmlns:r="http://schemas.openxmlformats.org/officeDocument/2006/relationships">
+<p:sld xmlns:a="http://schemas.openxmlformats.org/drawingml/2006/main" xmlns:r="http://schemas.openxmlformats.org/officeDocument/2006/relationships" xmlns:p="http://schemas.openxmlformats.org/presentationml/2006/main">
   <p:cSld>
     <p:spTree>
       <p:nvGrpSpPr>
@@ -12617,7 +13555,14 @@
         <p:cNvGrpSpPr/>
         <p:nvPr/>
       </p:nvGrpSpPr>
-      <p:grpSpPr/>
+      <p:grpSpPr>
+        <a:xfrm>
+          <a:off x="0" y="0"/>
+          <a:ext cx="0" cy="0"/>
+          <a:chOff x="0" y="0"/>
+          <a:chExt cx="0" cy="0"/>
+        </a:xfrm>
+      </p:grpSpPr>
       <p:sp>
         <p:nvSpPr>
           <p:cNvPr id="2" name="Rectangle 1"/>
@@ -12659,6 +13604,7 @@
           <a:lstStyle/>
           <a:p>
             <a:pPr algn="ctr"/>
+            <a:endParaRPr/>
           </a:p>
         </p:txBody>
       </p:sp>
@@ -12703,6 +13649,7 @@
           <a:lstStyle/>
           <a:p>
             <a:pPr algn="ctr"/>
+            <a:endParaRPr/>
           </a:p>
         </p:txBody>
       </p:sp>
@@ -12723,7 +13670,7 @@
           <a:noFill/>
         </p:spPr>
         <p:txBody>
-          <a:bodyPr wrap="square" lIns="0" rIns="0" tIns="0" bIns="0" anchor="t">
+          <a:bodyPr wrap="square" lIns="0" tIns="0" rIns="0" bIns="0" anchor="t">
             <a:spAutoFit/>
           </a:bodyPr>
           <a:lstStyle/>
@@ -12758,7 +13705,7 @@
           <a:noFill/>
         </p:spPr>
         <p:txBody>
-          <a:bodyPr wrap="square" lIns="0" rIns="0" tIns="0" bIns="0" anchor="t">
+          <a:bodyPr wrap="square" lIns="0" tIns="0" rIns="0" bIns="0" anchor="t">
             <a:spAutoFit/>
           </a:bodyPr>
           <a:lstStyle/>
@@ -12793,7 +13740,7 @@
           <a:noFill/>
         </p:spPr>
         <p:txBody>
-          <a:bodyPr wrap="square" lIns="0" rIns="0" tIns="0" bIns="0" anchor="t">
+          <a:bodyPr wrap="square" lIns="0" tIns="0" rIns="0" bIns="0" anchor="t">
             <a:spAutoFit/>
           </a:bodyPr>
           <a:lstStyle/>
@@ -12828,7 +13775,7 @@
           <a:noFill/>
         </p:spPr>
         <p:txBody>
-          <a:bodyPr wrap="square" lIns="0" rIns="0" tIns="0" bIns="0" anchor="t">
+          <a:bodyPr wrap="square" lIns="0" tIns="0" rIns="0" bIns="0" anchor="t">
             <a:spAutoFit/>
           </a:bodyPr>
           <a:lstStyle/>
@@ -12863,7 +13810,7 @@
           <a:noFill/>
         </p:spPr>
         <p:txBody>
-          <a:bodyPr wrap="square" lIns="0" rIns="0" tIns="0" bIns="0" anchor="t">
+          <a:bodyPr wrap="square" lIns="0" tIns="0" rIns="0" bIns="0" anchor="t">
             <a:spAutoFit/>
           </a:bodyPr>
           <a:lstStyle/>
@@ -12918,7 +13865,7 @@
           </a:fontRef>
         </p:style>
         <p:txBody>
-          <a:bodyPr rtlCol="0" anchor="ctr" lIns="0" rIns="0" tIns="0" bIns="0"/>
+          <a:bodyPr lIns="0" tIns="0" rIns="0" bIns="0" rtlCol="0" anchor="ctr"/>
           <a:lstStyle/>
           <a:p>
             <a:pPr algn="ctr"/>
@@ -12971,7 +13918,7 @@
           </a:fontRef>
         </p:style>
         <p:txBody>
-          <a:bodyPr rtlCol="0" anchor="ctr" lIns="0" rIns="0" tIns="0" bIns="0"/>
+          <a:bodyPr lIns="0" tIns="0" rIns="0" bIns="0" rtlCol="0" anchor="ctr"/>
           <a:lstStyle/>
           <a:p>
             <a:pPr algn="ctr"/>
@@ -13004,7 +13951,7 @@
           <a:noFill/>
         </p:spPr>
         <p:txBody>
-          <a:bodyPr wrap="square" lIns="0" rIns="0" tIns="0" bIns="0" anchor="t">
+          <a:bodyPr wrap="square" lIns="0" tIns="0" rIns="0" bIns="0" anchor="t">
             <a:spAutoFit/>
           </a:bodyPr>
           <a:lstStyle/>
@@ -13039,7 +13986,7 @@
           <a:noFill/>
         </p:spPr>
         <p:txBody>
-          <a:bodyPr wrap="square" lIns="0" rIns="0" tIns="0" bIns="0" anchor="t">
+          <a:bodyPr wrap="square" lIns="0" tIns="0" rIns="0" bIns="0" anchor="t">
             <a:spAutoFit/>
           </a:bodyPr>
           <a:lstStyle/>
@@ -13161,6 +14108,7 @@
           <a:lstStyle/>
           <a:p>
             <a:pPr algn="ctr"/>
+            <a:endParaRPr/>
           </a:p>
         </p:txBody>
       </p:sp>
@@ -13181,7 +14129,7 @@
           <a:noFill/>
         </p:spPr>
         <p:txBody>
-          <a:bodyPr wrap="square" lIns="0" rIns="0" tIns="0" bIns="0" anchor="t">
+          <a:bodyPr wrap="square" lIns="0" tIns="0" rIns="0" bIns="0" anchor="t">
             <a:spAutoFit/>
           </a:bodyPr>
           <a:lstStyle/>
@@ -13548,4 +14496,10 @@
   </a:objectDefaults>
   <a:extraClrSchemeLst/>
 </a:theme>
+</file>
+
+<file path=docMetadata/LabelInfo.xml><?xml version="1.0" encoding="utf-8"?>
+<clbl:labelList xmlns:clbl="http://schemas.microsoft.com/office/2020/mipLabelMetadata">
+  <clbl:label id="{f42aa342-8706-4288-bd11-ebb85995028c}" enabled="1" method="Standard" siteId="{72f988bf-86f1-41af-91ab-2d7cd011db47}" contentBits="0" removed="0"/>
+</clbl:labelList>
 </file>
</xml_diff>